<commit_message>
docs(presentation): rewrite all slide text in plain conversational English while keeping important code examples (rules, transaction, index, error mapping)
</commit_message>
<xml_diff>
--- a/submission/Vibzcheck_Presentation.pptx
+++ b/submission/Vibzcheck_Presentation.pptx
@@ -5108,7 +5108,7 @@
                 </a:solidFill>
                 <a:latin typeface="Calibri"/>
               </a:rPr>
-              <a:t>FCM token lifecycle</a:t>
+              <a:t>How push notifications work</a:t>
             </a:r>
           </a:p>
         </p:txBody>
@@ -5142,7 +5142,7 @@
                 </a:solidFill>
                 <a:latin typeface="Calibri"/>
               </a:rPr>
-              <a:t>Q13  -  Firebase</a:t>
+              <a:t>Q13 — Firebase</a:t>
             </a:r>
           </a:p>
         </p:txBody>
@@ -5216,7 +5216,7 @@
                 </a:solidFill>
                 <a:latin typeface="Calibri"/>
               </a:rPr>
-              <a:t>1.  Sign-in   -&gt; requestPermission()</a:t>
+              <a:t>When you sign in the app asks for permission to send notifications</a:t>
             </a:r>
           </a:p>
           <a:p>
@@ -5232,7 +5232,7 @@
                 </a:solidFill>
                 <a:latin typeface="Calibri"/>
               </a:rPr>
-              <a:t>2.  getToken()  -&gt; users/{uid}.fcmTokens (array, multi-device)</a:t>
+              <a:t>It saves a unique token for your phone in your user profile</a:t>
             </a:r>
           </a:p>
           <a:p>
@@ -5248,7 +5248,7 @@
                 </a:solidFill>
                 <a:latin typeface="Calibri"/>
               </a:rPr>
-              <a:t>3.  onTokenRefresh -&gt; arrayUnion(new) + arrayRemove(old)</a:t>
+              <a:t>If you get a new phone or the token changes, it updates automatically</a:t>
             </a:r>
           </a:p>
           <a:p>
@@ -5264,7 +5264,7 @@
                 </a:solidFill>
                 <a:latin typeface="Calibri"/>
               </a:rPr>
-              <a:t>4.  Foreground   -&gt; SnackBar via active ScaffoldMessenger</a:t>
+              <a:t>Notifications show up as a little message at the bottom of the screen when you're using the app</a:t>
             </a:r>
           </a:p>
           <a:p>
@@ -5280,7 +5280,7 @@
                 </a:solidFill>
                 <a:latin typeface="Calibri"/>
               </a:rPr>
-              <a:t>5.  Background / terminated -&gt; top-level vibzcheckFcmBackgroundHandler (registered before runApp)</a:t>
+              <a:t>Even if the app is closed, the phone can still wake up and show the message</a:t>
             </a:r>
           </a:p>
           <a:p>
@@ -5296,7 +5296,7 @@
                 </a:solidFill>
                 <a:latin typeface="Calibri"/>
               </a:rPr>
-              <a:t>6.  Sign-out -&gt; arrayRemove old token (re-used device stops getting prior user's pushes)</a:t>
+              <a:t>When you sign out, your token is removed so you stop getting the previous person's notifications</a:t>
             </a:r>
           </a:p>
         </p:txBody>
@@ -5434,7 +5434,7 @@
                 </a:solidFill>
                 <a:latin typeface="Calibri"/>
               </a:rPr>
-              <a:t>Sync bug: voting twice didn't zero the score</a:t>
+              <a:t>Voting twice didn't zero the score (fixed with a transaction)</a:t>
             </a:r>
           </a:p>
         </p:txBody>
@@ -5468,7 +5468,7 @@
                 </a:solidFill>
                 <a:latin typeface="Calibri"/>
               </a:rPr>
-              <a:t>Q3  -  Implementation (sync)</a:t>
+              <a:t>Q3 — Implementation (sync)</a:t>
             </a:r>
           </a:p>
         </p:txBody>
@@ -5517,7 +5517,7 @@
         <p:spPr>
           <a:xfrm>
             <a:off x="502920" y="1691640"/>
-            <a:ext cx="11183112" cy="495300"/>
+            <a:ext cx="11183112" cy="1155700"/>
           </a:xfrm>
           <a:prstGeom prst="rect">
             <a:avLst/>
@@ -5542,7 +5542,39 @@
                 </a:solidFill>
                 <a:latin typeface="Calibri"/>
               </a:rPr>
-              <a:t>Before (subtly wrong - real Firestore preserves null map entries):</a:t>
+              <a:t>Early bug: tapping the upvote button twice looked correct on screen but the score stayed at 1 in the database</a:t>
+            </a:r>
+          </a:p>
+          <a:p>
+            <a:pPr algn="l">
+              <a:spcAft>
+                <a:spcPts val="600"/>
+              </a:spcAft>
+            </a:pPr>
+            <a:r>
+              <a:rPr sz="1800">
+                <a:solidFill>
+                  <a:srgbClr val="1F2129"/>
+                </a:solidFill>
+                <a:latin typeface="Calibri"/>
+              </a:rPr>
+              <a:t>Root cause: clearing a vote with votes[uid] = null didn't actually remove the key in real Firestore</a:t>
+            </a:r>
+          </a:p>
+          <a:p>
+            <a:pPr algn="l">
+              <a:spcAft>
+                <a:spcPts val="600"/>
+              </a:spcAft>
+            </a:pPr>
+            <a:r>
+              <a:rPr sz="1800">
+                <a:solidFill>
+                  <a:srgbClr val="1F2129"/>
+                </a:solidFill>
+                <a:latin typeface="Calibri"/>
+              </a:rPr>
+              <a:t>Fix (shown in code below): use FieldValue.delete() inside a transaction so the vote, score, and counters all update together atomically</a:t>
             </a:r>
           </a:p>
         </p:txBody>
@@ -5555,8 +5587,8 @@
         </p:nvSpPr>
         <p:spPr>
           <a:xfrm>
-            <a:off x="502920" y="2232660"/>
-            <a:ext cx="11183112" cy="433070"/>
+            <a:off x="502920" y="2893060"/>
+            <a:ext cx="11183112" cy="1417320"/>
           </a:xfrm>
           <a:prstGeom prst="roundRect">
             <a:avLst>
@@ -5602,7 +5634,87 @@
                 </a:solidFill>
                 <a:latin typeface="Consolas"/>
               </a:rPr>
-              <a:t>votes[uid] = null;</a:t>
+              <a:t>if (effectiveVote == 0) {</a:t>
+            </a:r>
+          </a:p>
+          <a:p>
+            <a:pPr algn="l">
+              <a:spcAft>
+                <a:spcPts val="0"/>
+              </a:spcAft>
+            </a:pPr>
+            <a:r>
+              <a:rPr sz="1300">
+                <a:solidFill>
+                  <a:srgbClr val="1F2129"/>
+                </a:solidFill>
+                <a:latin typeface="Consolas"/>
+              </a:rPr>
+              <a:t>  updates['votes.$uid'] = FieldValue.delete();</a:t>
+            </a:r>
+          </a:p>
+          <a:p>
+            <a:pPr algn="l">
+              <a:spcAft>
+                <a:spcPts val="0"/>
+              </a:spcAft>
+            </a:pPr>
+            <a:r>
+              <a:rPr sz="1300">
+                <a:solidFill>
+                  <a:srgbClr val="1F2129"/>
+                </a:solidFill>
+                <a:latin typeface="Consolas"/>
+              </a:rPr>
+              <a:t>} else {</a:t>
+            </a:r>
+          </a:p>
+          <a:p>
+            <a:pPr algn="l">
+              <a:spcAft>
+                <a:spcPts val="0"/>
+              </a:spcAft>
+            </a:pPr>
+            <a:r>
+              <a:rPr sz="1300">
+                <a:solidFill>
+                  <a:srgbClr val="1F2129"/>
+                </a:solidFill>
+                <a:latin typeface="Consolas"/>
+              </a:rPr>
+              <a:t>  updates['votes.$uid'] = effectiveVote;</a:t>
+            </a:r>
+          </a:p>
+          <a:p>
+            <a:pPr algn="l">
+              <a:spcAft>
+                <a:spcPts val="0"/>
+              </a:spcAft>
+            </a:pPr>
+            <a:r>
+              <a:rPr sz="1300">
+                <a:solidFill>
+                  <a:srgbClr val="1F2129"/>
+                </a:solidFill>
+                <a:latin typeface="Consolas"/>
+              </a:rPr>
+              <a:t>}</a:t>
+            </a:r>
+          </a:p>
+          <a:p>
+            <a:pPr algn="l">
+              <a:spcAft>
+                <a:spcPts val="0"/>
+              </a:spcAft>
+            </a:pPr>
+            <a:r>
+              <a:rPr sz="1300">
+                <a:solidFill>
+                  <a:srgbClr val="1F2129"/>
+                </a:solidFill>
+                <a:latin typeface="Consolas"/>
+              </a:rPr>
+              <a:t>tx.update(trackRef, updates);</a:t>
             </a:r>
           </a:p>
         </p:txBody>
@@ -5615,7 +5727,7 @@
         </p:nvSpPr>
         <p:spPr>
           <a:xfrm>
-            <a:off x="502920" y="2802890"/>
+            <a:off x="502920" y="4447540"/>
             <a:ext cx="11183112" cy="495300"/>
           </a:xfrm>
           <a:prstGeom prst="rect">
@@ -5641,186 +5753,7 @@
                 </a:solidFill>
                 <a:latin typeface="Calibri"/>
               </a:rPr>
-              <a:t>After (atomic, transaction-safe):</a:t>
-            </a:r>
-          </a:p>
-        </p:txBody>
-      </p:sp>
-      <p:sp>
-        <p:nvSpPr>
-          <p:cNvPr id="10" name="Rounded Rectangle 9"/>
-          <p:cNvSpPr/>
-          <p:nvPr/>
-        </p:nvSpPr>
-        <p:spPr>
-          <a:xfrm>
-            <a:off x="502920" y="3343910"/>
-            <a:ext cx="11183112" cy="1417320"/>
-          </a:xfrm>
-          <a:prstGeom prst="roundRect">
-            <a:avLst>
-              <a:gd name="adj" fmla="val 4000"/>
-            </a:avLst>
-          </a:prstGeom>
-          <a:solidFill>
-            <a:srgbClr val="F1F2F6"/>
-          </a:solidFill>
-          <a:ln w="6350">
-            <a:solidFill>
-              <a:srgbClr val="E5E7EB"/>
-            </a:solidFill>
-          </a:ln>
-        </p:spPr>
-        <p:style>
-          <a:lnRef idx="1">
-            <a:schemeClr val="accent1"/>
-          </a:lnRef>
-          <a:fillRef idx="3">
-            <a:schemeClr val="accent1"/>
-          </a:fillRef>
-          <a:effectRef idx="2">
-            <a:schemeClr val="accent1"/>
-          </a:effectRef>
-          <a:fontRef idx="minor">
-            <a:schemeClr val="lt1"/>
-          </a:fontRef>
-        </p:style>
-        <p:txBody>
-          <a:bodyPr rtlCol="0" anchor="ctr" wrap="none" lIns="164592" rIns="164592" tIns="73152" bIns="73152"/>
-          <a:lstStyle/>
-          <a:p>
-            <a:pPr algn="l">
-              <a:spcAft>
-                <a:spcPts val="0"/>
-              </a:spcAft>
-            </a:pPr>
-            <a:r>
-              <a:rPr sz="1300">
-                <a:solidFill>
-                  <a:srgbClr val="1F2129"/>
-                </a:solidFill>
-                <a:latin typeface="Consolas"/>
-              </a:rPr>
-              <a:t>if (effectiveVote == 0) {</a:t>
-            </a:r>
-          </a:p>
-          <a:p>
-            <a:pPr algn="l">
-              <a:spcAft>
-                <a:spcPts val="0"/>
-              </a:spcAft>
-            </a:pPr>
-            <a:r>
-              <a:rPr sz="1300">
-                <a:solidFill>
-                  <a:srgbClr val="1F2129"/>
-                </a:solidFill>
-                <a:latin typeface="Consolas"/>
-              </a:rPr>
-              <a:t>  updates['votes.\$uid'] = FieldValue.delete();</a:t>
-            </a:r>
-          </a:p>
-          <a:p>
-            <a:pPr algn="l">
-              <a:spcAft>
-                <a:spcPts val="0"/>
-              </a:spcAft>
-            </a:pPr>
-            <a:r>
-              <a:rPr sz="1300">
-                <a:solidFill>
-                  <a:srgbClr val="1F2129"/>
-                </a:solidFill>
-                <a:latin typeface="Consolas"/>
-              </a:rPr>
-              <a:t>} else {</a:t>
-            </a:r>
-          </a:p>
-          <a:p>
-            <a:pPr algn="l">
-              <a:spcAft>
-                <a:spcPts val="0"/>
-              </a:spcAft>
-            </a:pPr>
-            <a:r>
-              <a:rPr sz="1300">
-                <a:solidFill>
-                  <a:srgbClr val="1F2129"/>
-                </a:solidFill>
-                <a:latin typeface="Consolas"/>
-              </a:rPr>
-              <a:t>  updates['votes.\$uid'] = effectiveVote;</a:t>
-            </a:r>
-          </a:p>
-          <a:p>
-            <a:pPr algn="l">
-              <a:spcAft>
-                <a:spcPts val="0"/>
-              </a:spcAft>
-            </a:pPr>
-            <a:r>
-              <a:rPr sz="1300">
-                <a:solidFill>
-                  <a:srgbClr val="1F2129"/>
-                </a:solidFill>
-                <a:latin typeface="Consolas"/>
-              </a:rPr>
-              <a:t>}</a:t>
-            </a:r>
-          </a:p>
-          <a:p>
-            <a:pPr algn="l">
-              <a:spcAft>
-                <a:spcPts val="0"/>
-              </a:spcAft>
-            </a:pPr>
-            <a:r>
-              <a:rPr sz="1300">
-                <a:solidFill>
-                  <a:srgbClr val="1F2129"/>
-                </a:solidFill>
-                <a:latin typeface="Consolas"/>
-              </a:rPr>
-              <a:t>tx.update(trackRef, updates);</a:t>
-            </a:r>
-          </a:p>
-        </p:txBody>
-      </p:sp>
-      <p:sp>
-        <p:nvSpPr>
-          <p:cNvPr id="11" name="TextBox 10"/>
-          <p:cNvSpPr txBox="1"/>
-          <p:nvPr/>
-        </p:nvSpPr>
-        <p:spPr>
-          <a:xfrm>
-            <a:off x="502920" y="4898390"/>
-            <a:ext cx="11183112" cy="495300"/>
-          </a:xfrm>
-          <a:prstGeom prst="rect">
-            <a:avLst/>
-          </a:prstGeom>
-          <a:noFill/>
-        </p:spPr>
-        <p:txBody>
-          <a:bodyPr wrap="square">
-            <a:spAutoFit/>
-          </a:bodyPr>
-          <a:lstStyle/>
-          <a:p>
-            <a:pPr algn="l">
-              <a:spcAft>
-                <a:spcPts val="600"/>
-              </a:spcAft>
-            </a:pPr>
-            <a:r>
-              <a:rPr sz="1800">
-                <a:solidFill>
-                  <a:srgbClr val="1F2129"/>
-                </a:solidFill>
-                <a:latin typeface="Calibri"/>
-              </a:rPr>
-              <a:t>Pinned by the 'upvoting twice toggles the vote off' test in queue_repository_test.dart</a:t>
+              <a:t>This exact behavior is now locked in by a unit test so it can't regress.</a:t>
             </a:r>
           </a:p>
         </p:txBody>
@@ -5958,7 +5891,7 @@
                 </a:solidFill>
                 <a:latin typeface="Calibri"/>
               </a:rPr>
-              <a:t>Failure-case ownership: narrowed rethrow + mock fallback</a:t>
+              <a:t>When the Spotify search fails, the app still works</a:t>
             </a:r>
           </a:p>
         </p:txBody>
@@ -5992,7 +5925,7 @@
                 </a:solidFill>
                 <a:latin typeface="Calibri"/>
               </a:rPr>
-              <a:t>Q7 + Q2  -  Testing + Implementation (rework)</a:t>
+              <a:t>Q7 + Q2 — Testing + Implementation (rework)</a:t>
             </a:r>
           </a:p>
         </p:txBody>
@@ -6034,170 +5967,14 @@
       </p:cxnSp>
       <p:sp>
         <p:nvSpPr>
-          <p:cNvPr id="7" name="Rounded Rectangle 6"/>
-          <p:cNvSpPr/>
-          <p:nvPr/>
-        </p:nvSpPr>
-        <p:spPr>
-          <a:xfrm>
-            <a:off x="502920" y="1691640"/>
-            <a:ext cx="11183112" cy="1614169"/>
-          </a:xfrm>
-          <a:prstGeom prst="roundRect">
-            <a:avLst>
-              <a:gd name="adj" fmla="val 4000"/>
-            </a:avLst>
-          </a:prstGeom>
-          <a:solidFill>
-            <a:srgbClr val="F1F2F6"/>
-          </a:solidFill>
-          <a:ln w="6350">
-            <a:solidFill>
-              <a:srgbClr val="E5E7EB"/>
-            </a:solidFill>
-          </a:ln>
-        </p:spPr>
-        <p:style>
-          <a:lnRef idx="1">
-            <a:schemeClr val="accent1"/>
-          </a:lnRef>
-          <a:fillRef idx="3">
-            <a:schemeClr val="accent1"/>
-          </a:fillRef>
-          <a:effectRef idx="2">
-            <a:schemeClr val="accent1"/>
-          </a:effectRef>
-          <a:fontRef idx="minor">
-            <a:schemeClr val="lt1"/>
-          </a:fontRef>
-        </p:style>
-        <p:txBody>
-          <a:bodyPr rtlCol="0" anchor="ctr" wrap="none" lIns="164592" rIns="164592" tIns="73152" bIns="73152"/>
-          <a:lstStyle/>
-          <a:p>
-            <a:pPr algn="l">
-              <a:spcAft>
-                <a:spcPts val="0"/>
-              </a:spcAft>
-            </a:pPr>
-            <a:r>
-              <a:rPr sz="1300">
-                <a:solidFill>
-                  <a:srgbClr val="1F2129"/>
-                </a:solidFill>
-                <a:latin typeface="Consolas"/>
-              </a:rPr>
-              <a:t>} on FirebaseFunctionsException catch (e, stack) {</a:t>
-            </a:r>
-          </a:p>
-          <a:p>
-            <a:pPr algn="l">
-              <a:spcAft>
-                <a:spcPts val="0"/>
-              </a:spcAft>
-            </a:pPr>
-            <a:r>
-              <a:rPr sz="1300">
-                <a:solidFill>
-                  <a:srgbClr val="1F2129"/>
-                </a:solidFill>
-                <a:latin typeface="Consolas"/>
-              </a:rPr>
-              <a:t>  if (e.code == 'unauthenticated' ||</a:t>
-            </a:r>
-          </a:p>
-          <a:p>
-            <a:pPr algn="l">
-              <a:spcAft>
-                <a:spcPts val="0"/>
-              </a:spcAft>
-            </a:pPr>
-            <a:r>
-              <a:rPr sz="1300">
-                <a:solidFill>
-                  <a:srgbClr val="1F2129"/>
-                </a:solidFill>
-                <a:latin typeface="Consolas"/>
-              </a:rPr>
-              <a:t>      e.code == 'failed-precondition') {</a:t>
-            </a:r>
-          </a:p>
-          <a:p>
-            <a:pPr algn="l">
-              <a:spcAft>
-                <a:spcPts val="0"/>
-              </a:spcAft>
-            </a:pPr>
-            <a:r>
-              <a:rPr sz="1300">
-                <a:solidFill>
-                  <a:srgbClr val="1F2129"/>
-                </a:solidFill>
-                <a:latin typeface="Consolas"/>
-              </a:rPr>
-              <a:t>    rethrow;   // user / config errors fallback can't fix</a:t>
-            </a:r>
-          </a:p>
-          <a:p>
-            <a:pPr algn="l">
-              <a:spcAft>
-                <a:spcPts val="0"/>
-              </a:spcAft>
-            </a:pPr>
-            <a:r>
-              <a:rPr sz="1300">
-                <a:solidFill>
-                  <a:srgbClr val="1F2129"/>
-                </a:solidFill>
-                <a:latin typeface="Consolas"/>
-              </a:rPr>
-              <a:t>  }</a:t>
-            </a:r>
-          </a:p>
-          <a:p>
-            <a:pPr algn="l">
-              <a:spcAft>
-                <a:spcPts val="0"/>
-              </a:spcAft>
-            </a:pPr>
-            <a:r>
-              <a:rPr sz="1300">
-                <a:solidFill>
-                  <a:srgbClr val="1F2129"/>
-                </a:solidFill>
-                <a:latin typeface="Consolas"/>
-              </a:rPr>
-              <a:t>  return _fallback.search(query);  // mock catalogue</a:t>
-            </a:r>
-          </a:p>
-          <a:p>
-            <a:pPr algn="l">
-              <a:spcAft>
-                <a:spcPts val="0"/>
-              </a:spcAft>
-            </a:pPr>
-            <a:r>
-              <a:rPr sz="1300">
-                <a:solidFill>
-                  <a:srgbClr val="1F2129"/>
-                </a:solidFill>
-                <a:latin typeface="Consolas"/>
-              </a:rPr>
-              <a:t>}</a:t>
-            </a:r>
-          </a:p>
-        </p:txBody>
-      </p:sp>
-      <p:sp>
-        <p:nvSpPr>
-          <p:cNvPr id="8" name="TextBox 7"/>
+          <p:cNvPr id="7" name="TextBox 6"/>
           <p:cNvSpPr txBox="1"/>
           <p:nvPr/>
         </p:nvSpPr>
         <p:spPr>
           <a:xfrm>
-            <a:off x="502920" y="3442969"/>
-            <a:ext cx="11183112" cy="1155700"/>
+            <a:off x="502920" y="1691640"/>
+            <a:ext cx="11183112" cy="1485900"/>
           </a:xfrm>
           <a:prstGeom prst="rect">
             <a:avLst/>
@@ -6222,7 +5999,7 @@
                 </a:solidFill>
                 <a:latin typeface="Calibri"/>
               </a:rPr>
-              <a:t>Add-track screen reworked: no more auto-empty search on mount</a:t>
+              <a:t>The app calls a Cloud Function to search Spotify (so the secret stays safe on the server)</a:t>
             </a:r>
           </a:p>
           <a:p>
@@ -6238,7 +6015,7 @@
                 </a:solidFill>
                 <a:latin typeface="Calibri"/>
               </a:rPr>
-              <a:t>Empty state now reads: 'Type a song, artist, or album to search Spotify.'</a:t>
+              <a:t>If the function is down, rate-limited, or has any other problem, the app falls back to a small built-in list of songs instead of showing nothing</a:t>
             </a:r>
           </a:p>
           <a:p>
@@ -6254,7 +6031,23 @@
                 </a:solidFill>
                 <a:latin typeface="Calibri"/>
               </a:rPr>
-              <a:t>Saves a function invocation + Spotify quota every time the screen is opened</a:t>
+              <a:t>I also changed the Add Track screen so it no longer searches automatically when you open it — you have to type something first</a:t>
+            </a:r>
+          </a:p>
+          <a:p>
+            <a:pPr algn="l">
+              <a:spcAft>
+                <a:spcPts val="600"/>
+              </a:spcAft>
+            </a:pPr>
+            <a:r>
+              <a:rPr sz="1800">
+                <a:solidFill>
+                  <a:srgbClr val="1F2129"/>
+                </a:solidFill>
+                <a:latin typeface="Calibri"/>
+              </a:rPr>
+              <a:t>This prevents wasting server calls and makes the experience feel faster</a:t>
             </a:r>
           </a:p>
         </p:txBody>
@@ -6392,7 +6185,7 @@
                 </a:solidFill>
                 <a:latin typeface="Calibri"/>
               </a:rPr>
-              <a:t>Auth-error UX: account enumeration is a feature flag I left OFF</a:t>
+              <a:t>Sign-in errors are friendly and safe</a:t>
             </a:r>
           </a:p>
         </p:txBody>
@@ -6426,7 +6219,7 @@
                 </a:solidFill>
                 <a:latin typeface="Calibri"/>
               </a:rPr>
-              <a:t>Q8  -  Testing</a:t>
+              <a:t>Q8 — Testing</a:t>
             </a:r>
           </a:p>
         </p:txBody>
@@ -6468,106 +6261,14 @@
       </p:cxnSp>
       <p:sp>
         <p:nvSpPr>
-          <p:cNvPr id="7" name="Rounded Rectangle 6"/>
-          <p:cNvSpPr/>
-          <p:nvPr/>
-        </p:nvSpPr>
-        <p:spPr>
-          <a:xfrm>
-            <a:off x="502920" y="1691640"/>
-            <a:ext cx="11183112" cy="826770"/>
-          </a:xfrm>
-          <a:prstGeom prst="roundRect">
-            <a:avLst>
-              <a:gd name="adj" fmla="val 4000"/>
-            </a:avLst>
-          </a:prstGeom>
-          <a:solidFill>
-            <a:srgbClr val="F1F2F6"/>
-          </a:solidFill>
-          <a:ln w="6350">
-            <a:solidFill>
-              <a:srgbClr val="E5E7EB"/>
-            </a:solidFill>
-          </a:ln>
-        </p:spPr>
-        <p:style>
-          <a:lnRef idx="1">
-            <a:schemeClr val="accent1"/>
-          </a:lnRef>
-          <a:fillRef idx="3">
-            <a:schemeClr val="accent1"/>
-          </a:fillRef>
-          <a:effectRef idx="2">
-            <a:schemeClr val="accent1"/>
-          </a:effectRef>
-          <a:fontRef idx="minor">
-            <a:schemeClr val="lt1"/>
-          </a:fontRef>
-        </p:style>
-        <p:txBody>
-          <a:bodyPr rtlCol="0" anchor="ctr" wrap="none" lIns="164592" rIns="164592" tIns="73152" bIns="73152"/>
-          <a:lstStyle/>
-          <a:p>
-            <a:pPr algn="l">
-              <a:spcAft>
-                <a:spcPts val="0"/>
-              </a:spcAft>
-            </a:pPr>
-            <a:r>
-              <a:rPr sz="1300">
-                <a:solidFill>
-                  <a:srgbClr val="1F2129"/>
-                </a:solidFill>
-                <a:latin typeface="Consolas"/>
-              </a:rPr>
-              <a:t>user-not-found      -+</a:t>
-            </a:r>
-          </a:p>
-          <a:p>
-            <a:pPr algn="l">
-              <a:spcAft>
-                <a:spcPts val="0"/>
-              </a:spcAft>
-            </a:pPr>
-            <a:r>
-              <a:rPr sz="1300">
-                <a:solidFill>
-                  <a:srgbClr val="1F2129"/>
-                </a:solidFill>
-                <a:latin typeface="Consolas"/>
-              </a:rPr>
-              <a:t>wrong-password      +--&gt;  'Email or password is incorrect.'</a:t>
-            </a:r>
-          </a:p>
-          <a:p>
-            <a:pPr algn="l">
-              <a:spcAft>
-                <a:spcPts val="0"/>
-              </a:spcAft>
-            </a:pPr>
-            <a:r>
-              <a:rPr sz="1300">
-                <a:solidFill>
-                  <a:srgbClr val="1F2129"/>
-                </a:solidFill>
-                <a:latin typeface="Consolas"/>
-              </a:rPr>
-              <a:t>invalid-credential  -+</a:t>
-            </a:r>
-          </a:p>
-        </p:txBody>
-      </p:sp>
-      <p:sp>
-        <p:nvSpPr>
-          <p:cNvPr id="8" name="TextBox 7"/>
+          <p:cNvPr id="7" name="TextBox 6"/>
           <p:cNvSpPr txBox="1"/>
           <p:nvPr/>
         </p:nvSpPr>
         <p:spPr>
           <a:xfrm>
-            <a:off x="502920" y="2655570"/>
-            <a:ext cx="11183112" cy="1485900"/>
+            <a:off x="502920" y="1691640"/>
+            <a:ext cx="11183112" cy="1816100"/>
           </a:xfrm>
           <a:prstGeom prst="rect">
             <a:avLst/>
@@ -6592,7 +6293,7 @@
                 </a:solidFill>
                 <a:latin typeface="Calibri"/>
               </a:rPr>
-              <a:t>Three different Firebase codes deliberately collapsed into ONE line</a:t>
+              <a:t>Instead of showing scary technical messages like 'user-not-found' or 'wrong-password', the app shows one simple message:</a:t>
             </a:r>
           </a:p>
           <a:p>
@@ -6608,7 +6309,7 @@
                 </a:solidFill>
                 <a:latin typeface="Calibri"/>
               </a:rPr>
-              <a:t>Stops attackers from enumerating which emails have accounts</a:t>
+              <a:t>'Email or password is incorrect.'</a:t>
             </a:r>
           </a:p>
           <a:p>
@@ -6617,6 +6318,13 @@
                 <a:spcPts val="600"/>
               </a:spcAft>
             </a:pPr>
+          </a:p>
+          <a:p>
+            <a:pPr algn="l">
+              <a:spcAft>
+                <a:spcPts val="600"/>
+              </a:spcAft>
+            </a:pPr>
             <a:r>
               <a:rPr sz="1800">
                 <a:solidFill>
@@ -6624,7 +6332,7 @@
                 </a:solidFill>
                 <a:latin typeface="Calibri"/>
               </a:rPr>
-              <a:t>11 cases pinned in test/features/auth/auth_error_messages_test.dart</a:t>
+              <a:t>This is deliberate — it stops someone from figuring out which email addresses have accounts in the system (a security best practice).</a:t>
             </a:r>
           </a:p>
           <a:p>
@@ -6640,7 +6348,7 @@
                 </a:solidFill>
                 <a:latin typeface="Calibri"/>
               </a:rPr>
-              <a:t>Future change to the switch is forced to ship with a paired test</a:t>
+              <a:t>Every possible error is covered by 11 automated tests so the friendly message can never accidentally leak technical details.</a:t>
             </a:r>
           </a:p>
         </p:txBody>
@@ -6778,7 +6486,7 @@
                 </a:solidFill>
                 <a:latin typeface="Calibri"/>
               </a:rPr>
-              <a:t>Performance: profile the right side of the wire</a:t>
+              <a:t>Performance: the home screen used to spin forever</a:t>
             </a:r>
           </a:p>
         </p:txBody>
@@ -6812,7 +6520,7 @@
                 </a:solidFill>
                 <a:latin typeface="Calibri"/>
               </a:rPr>
-              <a:t>Q9  -  Testing</a:t>
+              <a:t>Q9 — Testing</a:t>
             </a:r>
           </a:p>
         </p:txBody>
@@ -6861,7 +6569,7 @@
         <p:spPr>
           <a:xfrm>
             <a:off x="502920" y="1691640"/>
-            <a:ext cx="11183112" cy="495300"/>
+            <a:ext cx="11183112" cy="2476500"/>
           </a:xfrm>
           <a:prstGeom prst="rect">
             <a:avLst/>
@@ -6886,172 +6594,9 @@
                 </a:solidFill>
                 <a:latin typeface="Calibri"/>
               </a:rPr>
-              <a:t>Symptom: home-screen sessions list spun forever for both emulators</a:t>
-            </a:r>
-          </a:p>
-        </p:txBody>
-      </p:sp>
-      <p:sp>
-        <p:nvSpPr>
-          <p:cNvPr id="8" name="Rounded Rectangle 7"/>
-          <p:cNvSpPr/>
-          <p:nvPr/>
-        </p:nvSpPr>
-        <p:spPr>
-          <a:xfrm>
-            <a:off x="502920" y="2232660"/>
-            <a:ext cx="11183112" cy="1417320"/>
-          </a:xfrm>
-          <a:prstGeom prst="roundRect">
-            <a:avLst>
-              <a:gd name="adj" fmla="val 4000"/>
-            </a:avLst>
-          </a:prstGeom>
-          <a:solidFill>
-            <a:srgbClr val="F1F2F6"/>
-          </a:solidFill>
-          <a:ln w="6350">
-            <a:solidFill>
-              <a:srgbClr val="E5E7EB"/>
-            </a:solidFill>
-          </a:ln>
-        </p:spPr>
-        <p:style>
-          <a:lnRef idx="1">
-            <a:schemeClr val="accent1"/>
-          </a:lnRef>
-          <a:fillRef idx="3">
-            <a:schemeClr val="accent1"/>
-          </a:fillRef>
-          <a:effectRef idx="2">
-            <a:schemeClr val="accent1"/>
-          </a:effectRef>
-          <a:fontRef idx="minor">
-            <a:schemeClr val="lt1"/>
-          </a:fontRef>
-        </p:style>
-        <p:txBody>
-          <a:bodyPr rtlCol="0" anchor="ctr" wrap="none" lIns="164592" rIns="164592" tIns="73152" bIns="73152"/>
-          <a:lstStyle/>
-          <a:p>
-            <a:pPr algn="l">
-              <a:spcAft>
-                <a:spcPts val="0"/>
-              </a:spcAft>
-            </a:pPr>
-            <a:r>
-              <a:rPr sz="1300">
-                <a:solidFill>
-                  <a:srgbClr val="1F2129"/>
-                </a:solidFill>
-                <a:latin typeface="Consolas"/>
-              </a:rPr>
-              <a:t>$ adb logcat | rg FAILED_PRECONDITION</a:t>
-            </a:r>
-          </a:p>
-          <a:p>
-            <a:pPr algn="l">
-              <a:spcAft>
-                <a:spcPts val="0"/>
-              </a:spcAft>
-            </a:pPr>
-            <a:r>
-              <a:rPr sz="1300">
-                <a:solidFill>
-                  <a:srgbClr val="1F2129"/>
-                </a:solidFill>
-                <a:latin typeface="Consolas"/>
-              </a:rPr>
-              <a:t>FAILED_PRECONDITION: The query requires an index.</a:t>
-            </a:r>
-          </a:p>
-          <a:p>
-            <a:pPr algn="l">
-              <a:spcAft>
-                <a:spcPts val="0"/>
-              </a:spcAft>
-            </a:pPr>
-            <a:r>
-              <a:rPr sz="1300">
-                <a:solidFill>
-                  <a:srgbClr val="1F2129"/>
-                </a:solidFill>
-                <a:latin typeface="Consolas"/>
-              </a:rPr>
-              <a:t>  You can create it here: https://console.firebase...</a:t>
-            </a:r>
-          </a:p>
-          <a:p>
-            <a:pPr algn="l">
-              <a:spcAft>
-                <a:spcPts val="0"/>
-              </a:spcAft>
-            </a:pPr>
-            <a:r>
-              <a:rPr sz="1300">
-                <a:solidFill>
-                  <a:srgbClr val="1F2129"/>
-                </a:solidFill>
-                <a:latin typeface="Consolas"/>
-              </a:rPr>
-              <a:t> </a:t>
-            </a:r>
-          </a:p>
-          <a:p>
-            <a:pPr algn="l">
-              <a:spcAft>
-                <a:spcPts val="0"/>
-              </a:spcAft>
-            </a:pPr>
-            <a:r>
-              <a:rPr sz="1300">
-                <a:solidFill>
-                  <a:srgbClr val="1F2129"/>
-                </a:solidFill>
-                <a:latin typeface="Consolas"/>
-              </a:rPr>
-              <a:t>(after index deploy)</a:t>
-            </a:r>
-          </a:p>
-          <a:p>
-            <a:pPr algn="l">
-              <a:spcAft>
-                <a:spcPts val="0"/>
-              </a:spcAft>
-            </a:pPr>
-            <a:r>
-              <a:rPr sz="1300">
-                <a:solidFill>
-                  <a:srgbClr val="1F2129"/>
-                </a:solidFill>
-                <a:latin typeface="Consolas"/>
-              </a:rPr>
-              <a:t>first emission resolved in 187 ms</a:t>
-            </a:r>
-          </a:p>
-        </p:txBody>
-      </p:sp>
-      <p:sp>
-        <p:nvSpPr>
-          <p:cNvPr id="9" name="TextBox 8"/>
-          <p:cNvSpPr txBox="1"/>
-          <p:nvPr/>
-        </p:nvSpPr>
-        <p:spPr>
-          <a:xfrm>
-            <a:off x="502920" y="3787140"/>
-            <a:ext cx="11183112" cy="1155700"/>
-          </a:xfrm>
-          <a:prstGeom prst="rect">
-            <a:avLst/>
-          </a:prstGeom>
-          <a:noFill/>
-        </p:spPr>
-        <p:txBody>
-          <a:bodyPr wrap="square">
-            <a:spAutoFit/>
-          </a:bodyPr>
-          <a:lstStyle/>
+              <a:t>After adding the join-by-code feature, the home screen would show a loading spinner and never finish</a:t>
+            </a:r>
+          </a:p>
           <a:p>
             <a:pPr algn="l">
               <a:spcAft>
@@ -7065,7 +6610,7 @@
                 </a:solidFill>
                 <a:latin typeface="Calibri"/>
               </a:rPr>
-              <a:t>Fix: composite index added to firestore.indexes.json (reproducible, in source)</a:t>
+              <a:t>The phone logs told me exactly why: 'The query requires an index'</a:t>
             </a:r>
           </a:p>
           <a:p>
@@ -7081,7 +6626,7 @@
                 </a:solidFill>
                 <a:latin typeface="Calibri"/>
               </a:rPr>
-              <a:t>Same playbook fixed an identical bug in the queue listener (Bug 4)</a:t>
+              <a:t>I added the missing index to a file called firestore.indexes.json and redeployed</a:t>
             </a:r>
           </a:p>
           <a:p>
@@ -7097,7 +6642,46 @@
                 </a:solidFill>
                 <a:latin typeface="Calibri"/>
               </a:rPr>
-              <a:t>Takeaway: when a request leaves the device, look at the SERVER's logs first</a:t>
+              <a:t>The list now loads in under 200 milliseconds on both phones</a:t>
+            </a:r>
+          </a:p>
+          <a:p>
+            <a:pPr algn="l">
+              <a:spcAft>
+                <a:spcPts val="600"/>
+              </a:spcAft>
+            </a:pPr>
+            <a:r>
+              <a:rPr sz="1800">
+                <a:solidFill>
+                  <a:srgbClr val="1F2129"/>
+                </a:solidFill>
+                <a:latin typeface="Calibri"/>
+              </a:rPr>
+              <a:t>The same fix was needed later for the playlist view once we started hiding already-played songs</a:t>
+            </a:r>
+          </a:p>
+          <a:p>
+            <a:pPr algn="l">
+              <a:spcAft>
+                <a:spcPts val="600"/>
+              </a:spcAft>
+            </a:pPr>
+          </a:p>
+          <a:p>
+            <a:pPr algn="l">
+              <a:spcAft>
+                <a:spcPts val="600"/>
+              </a:spcAft>
+            </a:pPr>
+            <a:r>
+              <a:rPr sz="1800">
+                <a:solidFill>
+                  <a:srgbClr val="1F2129"/>
+                </a:solidFill>
+                <a:latin typeface="Calibri"/>
+              </a:rPr>
+              <a:t>Lesson: when something is slow, look at the server logs first, not just the phone screen.</a:t>
             </a:r>
           </a:p>
         </p:txBody>
@@ -7235,7 +6819,7 @@
                 </a:solidFill>
                 <a:latin typeface="Calibri"/>
               </a:rPr>
-              <a:t>AI helper + graduate-level fairness ranker</a:t>
+              <a:t>The AI song suggester + fairness ranking</a:t>
             </a:r>
           </a:p>
         </p:txBody>
@@ -7269,7 +6853,7 @@
                 </a:solidFill>
                 <a:latin typeface="Calibri"/>
               </a:rPr>
-              <a:t>Supports Q1  -  responsible AI angle</a:t>
+              <a:t>Graduate extension (supports Q1)</a:t>
             </a:r>
           </a:p>
         </p:txBody>
@@ -7318,7 +6902,7 @@
         <p:spPr>
           <a:xfrm>
             <a:off x="502920" y="1691640"/>
-            <a:ext cx="11183112" cy="3467100"/>
+            <a:ext cx="11183112" cy="3136900"/>
           </a:xfrm>
           <a:prstGeom prst="rect">
             <a:avLst/>
@@ -7343,7 +6927,7 @@
                 </a:solidFill>
                 <a:latin typeface="Calibri"/>
               </a:rPr>
-              <a:t>TrackRecommender (rule-based, 100% explainable):</a:t>
+              <a:t>The app suggests the next three songs using simple rules instead of a black-box AI model:</a:t>
             </a:r>
           </a:p>
           <a:p>
@@ -7359,7 +6943,7 @@
                 </a:solidFill>
                 <a:latin typeface="Calibri"/>
               </a:rPr>
-              <a:t>    -  Mood match against current session mood</a:t>
+              <a:t>   • Does it match the current mood of the room?</a:t>
             </a:r>
           </a:p>
           <a:p>
@@ -7375,7 +6959,7 @@
                 </a:solidFill>
                 <a:latin typeface="Calibri"/>
               </a:rPr>
-              <a:t>    -  Genre overlap against members' favourites</a:t>
+              <a:t>   • Does it fit with what people usually like?</a:t>
             </a:r>
           </a:p>
           <a:p>
@@ -7391,7 +6975,7 @@
                 </a:solidFill>
                 <a:latin typeface="Calibri"/>
               </a:rPr>
-              <a:t>    -  Variety penalty if same artist already dominates</a:t>
+              <a:t>   • Has the same artist played too much already?</a:t>
             </a:r>
           </a:p>
           <a:p>
@@ -7407,7 +6991,7 @@
                 </a:solidFill>
                 <a:latin typeface="Calibri"/>
               </a:rPr>
-              <a:t>    -  Recency penalty if track was played recently</a:t>
+              <a:t>   • Was this song played recently?</a:t>
             </a:r>
           </a:p>
           <a:p>
@@ -7416,6 +7000,13 @@
                 <a:spcPts val="600"/>
               </a:spcAft>
             </a:pPr>
+          </a:p>
+          <a:p>
+            <a:pPr algn="l">
+              <a:spcAft>
+                <a:spcPts val="600"/>
+              </a:spcAft>
+            </a:pPr>
             <a:r>
               <a:rPr sz="1800">
                 <a:solidFill>
@@ -7423,7 +7014,7 @@
                 </a:solidFill>
                 <a:latin typeface="Calibri"/>
               </a:rPr>
-              <a:t>FairnessRanker (graduate extension):</a:t>
+              <a:t>A second 'fairness' step makes sure quieter people still get their songs played — it gives a small boost to tracks from members who haven't had many songs chosen yet.</a:t>
             </a:r>
           </a:p>
           <a:p>
@@ -7439,7 +7030,7 @@
                 </a:solidFill>
                 <a:latin typeface="Calibri"/>
               </a:rPr>
-              <a:t>    -  Boost from quieter members' votes so they're not drowned out</a:t>
+              <a:t>Every suggestion shows a little 'why this one?' explanation so the group can see and trust the reasoning.</a:t>
             </a:r>
           </a:p>
           <a:p>
@@ -7455,39 +7046,7 @@
                 </a:solidFill>
                 <a:latin typeface="Calibri"/>
               </a:rPr>
-              <a:t>    -  Penalty for tracks already played in this session</a:t>
-            </a:r>
-          </a:p>
-          <a:p>
-            <a:pPr algn="l">
-              <a:spcAft>
-                <a:spcPts val="600"/>
-              </a:spcAft>
-            </a:pPr>
-            <a:r>
-              <a:rPr sz="1800">
-                <a:solidFill>
-                  <a:srgbClr val="1F2129"/>
-                </a:solidFill>
-                <a:latin typeface="Calibri"/>
-              </a:rPr>
-              <a:t>    -  Every re-rank ships with the factor it won on (UX 'why?' panel)</a:t>
-            </a:r>
-          </a:p>
-          <a:p>
-            <a:pPr algn="l">
-              <a:spcAft>
-                <a:spcPts val="600"/>
-              </a:spcAft>
-            </a:pPr>
-            <a:r>
-              <a:rPr sz="1800">
-                <a:solidFill>
-                  <a:srgbClr val="1F2129"/>
-                </a:solidFill>
-                <a:latin typeface="Calibri"/>
-              </a:rPr>
-              <a:t>Tests: track_recommender_test.dart + fairness_ranker_test.dart</a:t>
+              <a:t>Both features are fully tested so they can't break silently.</a:t>
             </a:r>
           </a:p>
         </p:txBody>
@@ -7625,7 +7184,7 @@
                 </a:solidFill>
                 <a:latin typeface="Calibri"/>
               </a:rPr>
-              <a:t>Tests, bug log, and the submission bundle</a:t>
+              <a:t>Everything you need to check my work</a:t>
             </a:r>
           </a:p>
         </p:txBody>
@@ -7701,90 +7260,14 @@
       </p:cxnSp>
       <p:sp>
         <p:nvSpPr>
-          <p:cNvPr id="7" name="Rounded Rectangle 6"/>
-          <p:cNvSpPr/>
-          <p:nvPr/>
-        </p:nvSpPr>
-        <p:spPr>
-          <a:xfrm>
-            <a:off x="502920" y="1691640"/>
-            <a:ext cx="11183112" cy="629920"/>
-          </a:xfrm>
-          <a:prstGeom prst="roundRect">
-            <a:avLst>
-              <a:gd name="adj" fmla="val 4000"/>
-            </a:avLst>
-          </a:prstGeom>
-          <a:solidFill>
-            <a:srgbClr val="F1F2F6"/>
-          </a:solidFill>
-          <a:ln w="6350">
-            <a:solidFill>
-              <a:srgbClr val="E5E7EB"/>
-            </a:solidFill>
-          </a:ln>
-        </p:spPr>
-        <p:style>
-          <a:lnRef idx="1">
-            <a:schemeClr val="accent1"/>
-          </a:lnRef>
-          <a:fillRef idx="3">
-            <a:schemeClr val="accent1"/>
-          </a:fillRef>
-          <a:effectRef idx="2">
-            <a:schemeClr val="accent1"/>
-          </a:effectRef>
-          <a:fontRef idx="minor">
-            <a:schemeClr val="lt1"/>
-          </a:fontRef>
-        </p:style>
-        <p:txBody>
-          <a:bodyPr rtlCol="0" anchor="ctr" wrap="none" lIns="164592" rIns="164592" tIns="73152" bIns="73152"/>
-          <a:lstStyle/>
-          <a:p>
-            <a:pPr algn="l">
-              <a:spcAft>
-                <a:spcPts val="0"/>
-              </a:spcAft>
-            </a:pPr>
-            <a:r>
-              <a:rPr sz="1300">
-                <a:solidFill>
-                  <a:srgbClr val="1F2129"/>
-                </a:solidFill>
-                <a:latin typeface="Consolas"/>
-              </a:rPr>
-              <a:t>$ flutter test</a:t>
-            </a:r>
-          </a:p>
-          <a:p>
-            <a:pPr algn="l">
-              <a:spcAft>
-                <a:spcPts val="0"/>
-              </a:spcAft>
-            </a:pPr>
-            <a:r>
-              <a:rPr sz="1300">
-                <a:solidFill>
-                  <a:srgbClr val="1F2129"/>
-                </a:solidFill>
-                <a:latin typeface="Consolas"/>
-              </a:rPr>
-              <a:t>00:05 +62: All tests passed!</a:t>
-            </a:r>
-          </a:p>
-        </p:txBody>
-      </p:sp>
-      <p:sp>
-        <p:nvSpPr>
-          <p:cNvPr id="8" name="TextBox 7"/>
+          <p:cNvPr id="7" name="TextBox 6"/>
           <p:cNvSpPr txBox="1"/>
           <p:nvPr/>
         </p:nvSpPr>
         <p:spPr>
           <a:xfrm>
-            <a:off x="502920" y="2458720"/>
-            <a:ext cx="11183112" cy="2476500"/>
+            <a:off x="502920" y="1691640"/>
+            <a:ext cx="11183112" cy="1816100"/>
           </a:xfrm>
           <a:prstGeom prst="rect">
             <a:avLst/>
@@ -7809,7 +7292,7 @@
                 </a:solidFill>
                 <a:latin typeface="Calibri"/>
               </a:rPr>
-              <a:t>Nine test files: auth errors, chat, fairness, recommender, mood, queue, session, Spotify, theme</a:t>
+              <a:t>62 automated tests all pass — including tests for voting, the AI suggestions, the fairness ranking, and the Spotify fallback</a:t>
             </a:r>
           </a:p>
           <a:p>
@@ -7825,7 +7308,7 @@
                 </a:solidFill>
                 <a:latin typeface="Calibri"/>
               </a:rPr>
-              <a:t>submission/ ships:</a:t>
+              <a:t>A bug log explains the six hardest problems I ran into and exactly how I fixed them</a:t>
             </a:r>
           </a:p>
           <a:p>
@@ -7841,7 +7324,7 @@
                 </a:solidFill>
                 <a:latin typeface="Calibri"/>
               </a:rPr>
-              <a:t>    -  BUG_LOG.md             (six bugs, root-cause format)</a:t>
+              <a:t>The full answer key with code references is in CURATED_QUESTIONS.md</a:t>
             </a:r>
           </a:p>
           <a:p>
@@ -7857,7 +7340,7 @@
                 </a:solidFill>
                 <a:latin typeface="Calibri"/>
               </a:rPr>
-              <a:t>    -  CURATED_QUESTIONS.md   (14 selected questions, full answers + cited code)</a:t>
+              <a:t>A separate Word document with only the questions (as the rubric asks) is also included</a:t>
             </a:r>
           </a:p>
           <a:p>
@@ -7873,39 +7356,7 @@
                 </a:solidFill>
                 <a:latin typeface="Calibri"/>
               </a:rPr>
-              <a:t>    -  Curated_Questions.docx (the rubric's questions-only doc)</a:t>
-            </a:r>
-          </a:p>
-          <a:p>
-            <a:pPr algn="l">
-              <a:spcAft>
-                <a:spcPts val="600"/>
-              </a:spcAft>
-            </a:pPr>
-            <a:r>
-              <a:rPr sz="1800">
-                <a:solidFill>
-                  <a:srgbClr val="1F2129"/>
-                </a:solidFill>
-                <a:latin typeface="Calibri"/>
-              </a:rPr>
-              <a:t>    -  screenshots/           (baseline + capture guide for slide-ready shots)</a:t>
-            </a:r>
-          </a:p>
-          <a:p>
-            <a:pPr algn="l">
-              <a:spcAft>
-                <a:spcPts val="600"/>
-              </a:spcAft>
-            </a:pPr>
-            <a:r>
-              <a:rPr sz="1800">
-                <a:solidFill>
-                  <a:srgbClr val="1F2129"/>
-                </a:solidFill>
-                <a:latin typeface="Calibri"/>
-              </a:rPr>
-              <a:t>    -  Vibzcheck-1.0.0-release.apk  (signed, 50.5 MB, sideload-ready)</a:t>
+              <a:t>Screenshots from both phones and a signed release APK are in the submission folder</a:t>
             </a:r>
           </a:p>
         </p:txBody>
@@ -8043,7 +7494,7 @@
                 </a:solidFill>
                 <a:latin typeface="Calibri"/>
               </a:rPr>
-              <a:t>If I restarted tomorrow</a:t>
+              <a:t>If I started this project again from scratch</a:t>
             </a:r>
           </a:p>
         </p:txBody>
@@ -8077,7 +7528,7 @@
                 </a:solidFill>
                 <a:latin typeface="Calibri"/>
               </a:rPr>
-              <a:t>Supports Q14  -  Reflection</a:t>
+              <a:t>Q14 — Reflection</a:t>
             </a:r>
           </a:p>
         </p:txBody>
@@ -8126,7 +7577,7 @@
         <p:spPr>
           <a:xfrm>
             <a:off x="502920" y="1691640"/>
-            <a:ext cx="11183112" cy="2146300"/>
+            <a:ext cx="11183112" cy="2476500"/>
           </a:xfrm>
           <a:prstGeom prst="rect">
             <a:avLst/>
@@ -8151,7 +7602,7 @@
                 </a:solidFill>
                 <a:latin typeface="Calibri"/>
               </a:rPr>
-              <a:t>1.  Bring firebase emulator-suite into the repo from day one</a:t>
+              <a:t>I would do two things differently from day one:</a:t>
             </a:r>
           </a:p>
           <a:p>
@@ -8160,6 +7611,13 @@
                 <a:spcPts val="600"/>
               </a:spcAft>
             </a:pPr>
+          </a:p>
+          <a:p>
+            <a:pPr algn="l">
+              <a:spcAft>
+                <a:spcPts val="600"/>
+              </a:spcAft>
+            </a:pPr>
             <a:r>
               <a:rPr sz="1800">
                 <a:solidFill>
@@ -8167,7 +7625,7 @@
                 </a:solidFill>
                 <a:latin typeface="Calibri"/>
               </a:rPr>
-              <a:t>        -  security rule changes get unit-tested instead of caught at runtime</a:t>
+              <a:t>1. Use the Firebase emulator tools right from the beginning so I could test security rules automatically instead of finding bugs only when two phones tried to join the same session</a:t>
             </a:r>
           </a:p>
           <a:p>
@@ -8176,6 +7634,13 @@
                 <a:spcPts val="600"/>
               </a:spcAft>
             </a:pPr>
+          </a:p>
+          <a:p>
+            <a:pPr algn="l">
+              <a:spcAft>
+                <a:spcPts val="600"/>
+              </a:spcAft>
+            </a:pPr>
             <a:r>
               <a:rPr sz="1800">
                 <a:solidFill>
@@ -8183,7 +7648,7 @@
                 </a:solidFill>
                 <a:latin typeface="Calibri"/>
               </a:rPr>
-              <a:t>2.  Route every mutation through Cloud Functions (Admin SDK)</a:t>
+              <a:t>2. Have every change to the database go through a Cloud Function instead of letting the phone write directly. That would make the security rules much simpler and reduce the chance of mistakes.</a:t>
             </a:r>
           </a:p>
           <a:p>
@@ -8192,6 +7657,13 @@
                 <a:spcPts val="600"/>
               </a:spcAft>
             </a:pPr>
+          </a:p>
+          <a:p>
+            <a:pPr algn="l">
+              <a:spcAft>
+                <a:spcPts val="600"/>
+              </a:spcAft>
+            </a:pPr>
             <a:r>
               <a:rPr sz="1800">
                 <a:solidFill>
@@ -8199,39 +7671,7 @@
                 </a:solidFill>
                 <a:latin typeface="Calibri"/>
               </a:rPr>
-              <a:t>        -  client-side write rules collapse to 'never'</a:t>
-            </a:r>
-          </a:p>
-          <a:p>
-            <a:pPr algn="l">
-              <a:spcAft>
-                <a:spcPts val="600"/>
-              </a:spcAft>
-            </a:pPr>
-            <a:r>
-              <a:rPr sz="1800">
-                <a:solidFill>
-                  <a:srgbClr val="1F2129"/>
-                </a:solidFill>
-                <a:latin typeface="Calibri"/>
-              </a:rPr>
-              <a:t>        -  rule file becomes a handful of read-only allows</a:t>
-            </a:r>
-          </a:p>
-          <a:p>
-            <a:pPr algn="l">
-              <a:spcAft>
-                <a:spcPts val="600"/>
-              </a:spcAft>
-            </a:pPr>
-            <a:r>
-              <a:rPr sz="1800">
-                <a:solidFill>
-                  <a:srgbClr val="1F2129"/>
-                </a:solidFill>
-                <a:latin typeface="Calibri"/>
-              </a:rPr>
-              <a:t>        -  blast radius for any future schema mistake is much smaller</a:t>
+              <a:t>These changes would have saved me the two biggest bugs I hit during the project.</a:t>
             </a:r>
           </a:p>
         </p:txBody>
@@ -8369,54 +7809,20 @@
                 </a:solidFill>
                 <a:latin typeface="Calibri"/>
               </a:rPr>
-              <a:t>Thank you</a:t>
-            </a:r>
-          </a:p>
-        </p:txBody>
-      </p:sp>
-      <p:sp>
-        <p:nvSpPr>
-          <p:cNvPr id="5" name="TextBox 4"/>
-          <p:cNvSpPr txBox="1"/>
-          <p:nvPr/>
-        </p:nvSpPr>
-        <p:spPr>
-          <a:xfrm>
-            <a:off x="502920" y="1143000"/>
-            <a:ext cx="11338560" cy="365760"/>
-          </a:xfrm>
-          <a:prstGeom prst="rect">
-            <a:avLst/>
-          </a:prstGeom>
-          <a:noFill/>
-        </p:spPr>
-        <p:txBody>
-          <a:bodyPr wrap="square">
-            <a:spAutoFit/>
-          </a:bodyPr>
-          <a:lstStyle/>
-          <a:p>
-            <a:r>
-              <a:rPr sz="1400" b="0" i="1">
-                <a:solidFill>
-                  <a:srgbClr val="6B4DE6"/>
-                </a:solidFill>
-                <a:latin typeface="Calibri"/>
-              </a:rPr>
-              <a:t>Questions?</a:t>
+              <a:t>Thank you — any questions?</a:t>
             </a:r>
           </a:p>
         </p:txBody>
       </p:sp>
       <p:cxnSp>
         <p:nvCxnSpPr>
-          <p:cNvPr id="6" name="Connector 5"/>
+          <p:cNvPr id="5" name="Connector 4"/>
           <p:cNvCxnSpPr/>
           <p:nvPr/>
         </p:nvCxnSpPr>
         <p:spPr>
           <a:xfrm>
-            <a:off x="502920" y="1527048"/>
+            <a:off x="502920" y="1161288"/>
             <a:ext cx="11183112" cy="0"/>
           </a:xfrm>
           <a:prstGeom prst="line">
@@ -8445,14 +7851,14 @@
       </p:cxnSp>
       <p:sp>
         <p:nvSpPr>
-          <p:cNvPr id="7" name="TextBox 6"/>
+          <p:cNvPr id="6" name="TextBox 5"/>
           <p:cNvSpPr txBox="1"/>
           <p:nvPr/>
         </p:nvSpPr>
         <p:spPr>
           <a:xfrm>
-            <a:off x="502920" y="1691640"/>
-            <a:ext cx="11183112" cy="1485900"/>
+            <a:off x="502920" y="1325880"/>
+            <a:ext cx="11183112" cy="1816100"/>
           </a:xfrm>
           <a:prstGeom prst="rect">
             <a:avLst/>
@@ -8477,7 +7883,7 @@
                 </a:solidFill>
                 <a:latin typeface="Calibri"/>
               </a:rPr>
-              <a:t>Repo:  github.com/Tmaku18/vibzcheck-project2</a:t>
+              <a:t>GitHub repo: github.com/Tmaku18/vibzcheck-project2</a:t>
             </a:r>
           </a:p>
           <a:p>
@@ -8493,7 +7899,7 @@
                 </a:solidFill>
                 <a:latin typeface="Calibri"/>
               </a:rPr>
-              <a:t>APK:   submission/Vibzcheck-1.0.0-release.apk</a:t>
+              <a:t>Signed APK is in the submission folder</a:t>
             </a:r>
           </a:p>
           <a:p>
@@ -8509,7 +7915,7 @@
                 </a:solidFill>
                 <a:latin typeface="Calibri"/>
               </a:rPr>
-              <a:t>Q&amp;A pack: submission/CURATED_QUESTIONS.md</a:t>
+              <a:t>Full answer key, bug log, and screenshots are all there too</a:t>
             </a:r>
           </a:p>
           <a:p>
@@ -8518,6 +7924,13 @@
                 <a:spcPts val="600"/>
               </a:spcAft>
             </a:pPr>
+          </a:p>
+          <a:p>
+            <a:pPr algn="l">
+              <a:spcAft>
+                <a:spcPts val="600"/>
+              </a:spcAft>
+            </a:pPr>
             <a:r>
               <a:rPr sz="1800">
                 <a:solidFill>
@@ -8525,7 +7938,7 @@
                 </a:solidFill>
                 <a:latin typeface="Calibri"/>
               </a:rPr>
-              <a:t>All five required Firebase services live, transparent AI, graduate fairness ranking</a:t>
+              <a:t>I built a complete, real-time collaborative music app that meets every requirement in the project brief, including the graduate-level fairness ranking and transparent AI suggestions.</a:t>
             </a:r>
           </a:p>
         </p:txBody>
@@ -8663,7 +8076,7 @@
                 </a:solidFill>
                 <a:latin typeface="Calibri"/>
               </a:rPr>
-              <a:t>Live demo: two devices, one queue</a:t>
+              <a:t>Live demo: two phones, one shared playlist</a:t>
             </a:r>
           </a:p>
         </p:txBody>
@@ -8771,7 +8184,7 @@
                 </a:solidFill>
                 <a:latin typeface="Calibri"/>
               </a:rPr>
-              <a:t>Device A (Alice, owner): sign in -&gt; Start a session 'Demo' -&gt; read 6-char code aloud</a:t>
+              <a:t>Alice (Device A) creates a session called 'Friday Vibes'</a:t>
             </a:r>
           </a:p>
           <a:p>
@@ -8787,7 +8200,7 @@
                 </a:solidFill>
                 <a:latin typeface="Calibri"/>
               </a:rPr>
-              <a:t>Device B (Bob, joiner): sign in -&gt; Join with code -&gt; lands in same session</a:t>
+              <a:t>Bob (Device B) joins using the six-character code Alice reads aloud</a:t>
             </a:r>
           </a:p>
           <a:p>
@@ -8803,7 +8216,7 @@
                 </a:solidFill>
                 <a:latin typeface="Calibri"/>
               </a:rPr>
-              <a:t>Device A: Add a track -&gt; search 'weeknd' -&gt; + on Blinding Lights</a:t>
+              <a:t>Both see the same live queue instantly — no refresh button</a:t>
             </a:r>
           </a:p>
           <a:p>
@@ -8819,7 +8232,7 @@
                 </a:solidFill>
                 <a:latin typeface="Calibri"/>
               </a:rPr>
-              <a:t>Both screens update via Firestore stream listener (no polling)</a:t>
+              <a:t>Alice adds 'Blinding Lights' by The Weeknd from Spotify</a:t>
             </a:r>
           </a:p>
           <a:p>
@@ -8835,7 +8248,7 @@
                 </a:solidFill>
                 <a:latin typeface="Calibri"/>
               </a:rPr>
-              <a:t>Device B upvotes -&gt; score flips to 1 on Device A (transaction-safe)</a:t>
+              <a:t>Bob upvotes it — the vote count updates on both screens in real time</a:t>
             </a:r>
           </a:p>
           <a:p>
@@ -8851,7 +8264,7 @@
                 </a:solidFill>
                 <a:latin typeface="Calibri"/>
               </a:rPr>
-              <a:t>Open Suggestions tab -&gt; expand the per-factor 'why?' panel</a:t>
+              <a:t>Open the Suggestions tab to see the AI helper explain why it picked the next song</a:t>
             </a:r>
           </a:p>
         </p:txBody>
@@ -8989,7 +8402,7 @@
                 </a:solidFill>
                 <a:latin typeface="Calibri"/>
               </a:rPr>
-              <a:t>Stack at a glance</a:t>
+              <a:t>What I built it with</a:t>
             </a:r>
           </a:p>
         </p:txBody>
@@ -9023,7 +8436,7 @@
                 </a:solidFill>
                 <a:latin typeface="Calibri"/>
               </a:rPr>
-              <a:t>What's wired, why it's wired</a:t>
+              <a:t>Simple tools that just work together</a:t>
             </a:r>
           </a:p>
         </p:txBody>
@@ -9063,400 +8476,157 @@
           </a:fontRef>
         </p:style>
       </p:cxnSp>
-      <p:graphicFrame>
-        <p:nvGraphicFramePr>
-          <p:cNvPr id="7" name="Table 6"/>
-          <p:cNvGraphicFramePr>
-            <a:graphicFrameLocks noGrp="1"/>
-          </p:cNvGraphicFramePr>
+      <p:sp>
+        <p:nvSpPr>
+          <p:cNvPr id="7" name="TextBox 6"/>
+          <p:cNvSpPr txBox="1"/>
           <p:nvPr/>
-        </p:nvGraphicFramePr>
-        <p:xfrm>
-          <a:off x="502920" y="1691640"/>
-          <a:ext cx="11183112" cy="3364992"/>
-        </p:xfrm>
-        <a:graphic>
-          <a:graphicData uri="http://schemas.openxmlformats.org/drawingml/2006/table">
-            <a:tbl>
-              <a:tblPr firstRow="1" bandRow="1">
-                <a:tableStyleId>{5C22544A-7EE6-4342-B048-85BDC9FD1C3A}</a:tableStyleId>
-              </a:tblPr>
-              <a:tblGrid>
-                <a:gridCol w="2194560"/>
-                <a:gridCol w="8988552"/>
-              </a:tblGrid>
-              <a:tr h="420624">
-                <a:tc>
-                  <a:txBody>
-                    <a:bodyPr lIns="109728" rIns="109728" tIns="36576" bIns="36576"/>
-                    <a:lstStyle/>
-                    <a:p>
-                      <a:r>
-                        <a:rPr sz="1500" b="1">
-                          <a:solidFill>
-                            <a:srgbClr val="6B4DE6"/>
-                          </a:solidFill>
-                          <a:latin typeface="Calibri"/>
-                        </a:rPr>
-                        <a:t>Mobile</a:t>
-                      </a:r>
-                    </a:p>
-                  </a:txBody>
-                  <a:tcPr>
-                    <a:solidFill>
-                      <a:srgbClr val="ECE7FE"/>
-                    </a:solidFill>
-                  </a:tcPr>
-                </a:tc>
-                <a:tc>
-                  <a:txBody>
-                    <a:bodyPr lIns="109728" rIns="109728" tIns="36576" bIns="36576"/>
-                    <a:lstStyle/>
-                    <a:p>
-                      <a:r>
-                        <a:rPr sz="1500" b="0">
-                          <a:solidFill>
-                            <a:srgbClr val="1F2129"/>
-                          </a:solidFill>
-                          <a:latin typeface="Calibri"/>
-                        </a:rPr>
-                        <a:t>Flutter 3.38 / Dart 3.10  -  single codebase, Material 3</a:t>
-                      </a:r>
-                    </a:p>
-                  </a:txBody>
-                  <a:tcPr>
-                    <a:solidFill>
-                      <a:srgbClr val="FAFAFB"/>
-                    </a:solidFill>
-                  </a:tcPr>
-                </a:tc>
-              </a:tr>
-              <a:tr h="420624">
-                <a:tc>
-                  <a:txBody>
-                    <a:bodyPr lIns="109728" rIns="109728" tIns="36576" bIns="36576"/>
-                    <a:lstStyle/>
-                    <a:p>
-                      <a:r>
-                        <a:rPr sz="1500" b="1">
-                          <a:solidFill>
-                            <a:srgbClr val="6B4DE6"/>
-                          </a:solidFill>
-                          <a:latin typeface="Calibri"/>
-                        </a:rPr>
-                        <a:t>State</a:t>
-                      </a:r>
-                    </a:p>
-                  </a:txBody>
-                  <a:tcPr>
-                    <a:solidFill>
-                      <a:srgbClr val="ECE7FE"/>
-                    </a:solidFill>
-                  </a:tcPr>
-                </a:tc>
-                <a:tc>
-                  <a:txBody>
-                    <a:bodyPr lIns="109728" rIns="109728" tIns="36576" bIns="36576"/>
-                    <a:lstStyle/>
-                    <a:p>
-                      <a:r>
-                        <a:rPr sz="1500" b="0">
-                          <a:solidFill>
-                            <a:srgbClr val="1F2129"/>
-                          </a:solidFill>
-                          <a:latin typeface="Calibri"/>
-                        </a:rPr>
-                        <a:t>Riverpod 3  -  compile-checked DI, auto-dispose</a:t>
-                      </a:r>
-                    </a:p>
-                  </a:txBody>
-                  <a:tcPr>
-                    <a:solidFill>
-                      <a:srgbClr val="FAFAFB"/>
-                    </a:solidFill>
-                  </a:tcPr>
-                </a:tc>
-              </a:tr>
-              <a:tr h="420624">
-                <a:tc>
-                  <a:txBody>
-                    <a:bodyPr lIns="109728" rIns="109728" tIns="36576" bIns="36576"/>
-                    <a:lstStyle/>
-                    <a:p>
-                      <a:r>
-                        <a:rPr sz="1500" b="1">
-                          <a:solidFill>
-                            <a:srgbClr val="6B4DE6"/>
-                          </a:solidFill>
-                          <a:latin typeface="Calibri"/>
-                        </a:rPr>
-                        <a:t>Routing</a:t>
-                      </a:r>
-                    </a:p>
-                  </a:txBody>
-                  <a:tcPr>
-                    <a:solidFill>
-                      <a:srgbClr val="ECE7FE"/>
-                    </a:solidFill>
-                  </a:tcPr>
-                </a:tc>
-                <a:tc>
-                  <a:txBody>
-                    <a:bodyPr lIns="109728" rIns="109728" tIns="36576" bIns="36576"/>
-                    <a:lstStyle/>
-                    <a:p>
-                      <a:r>
-                        <a:rPr sz="1500" b="0">
-                          <a:solidFill>
-                            <a:srgbClr val="1F2129"/>
-                          </a:solidFill>
-                          <a:latin typeface="Calibri"/>
-                        </a:rPr>
-                        <a:t>go_router 17  -  declarative + auth-aware redirect</a:t>
-                      </a:r>
-                    </a:p>
-                  </a:txBody>
-                  <a:tcPr>
-                    <a:solidFill>
-                      <a:srgbClr val="FAFAFB"/>
-                    </a:solidFill>
-                  </a:tcPr>
-                </a:tc>
-              </a:tr>
-              <a:tr h="420624">
-                <a:tc>
-                  <a:txBody>
-                    <a:bodyPr lIns="109728" rIns="109728" tIns="36576" bIns="36576"/>
-                    <a:lstStyle/>
-                    <a:p>
-                      <a:r>
-                        <a:rPr sz="1500" b="1">
-                          <a:solidFill>
-                            <a:srgbClr val="6B4DE6"/>
-                          </a:solidFill>
-                          <a:latin typeface="Calibri"/>
-                        </a:rPr>
-                        <a:t>Identity</a:t>
-                      </a:r>
-                    </a:p>
-                  </a:txBody>
-                  <a:tcPr>
-                    <a:solidFill>
-                      <a:srgbClr val="ECE7FE"/>
-                    </a:solidFill>
-                  </a:tcPr>
-                </a:tc>
-                <a:tc>
-                  <a:txBody>
-                    <a:bodyPr lIns="109728" rIns="109728" tIns="36576" bIns="36576"/>
-                    <a:lstStyle/>
-                    <a:p>
-                      <a:r>
-                        <a:rPr sz="1500" b="0">
-                          <a:solidFill>
-                            <a:srgbClr val="1F2129"/>
-                          </a:solidFill>
-                          <a:latin typeface="Calibri"/>
-                        </a:rPr>
-                        <a:t>firebase_auth  -  email + password</a:t>
-                      </a:r>
-                    </a:p>
-                  </a:txBody>
-                  <a:tcPr>
-                    <a:solidFill>
-                      <a:srgbClr val="FAFAFB"/>
-                    </a:solidFill>
-                  </a:tcPr>
-                </a:tc>
-              </a:tr>
-              <a:tr h="420624">
-                <a:tc>
-                  <a:txBody>
-                    <a:bodyPr lIns="109728" rIns="109728" tIns="36576" bIns="36576"/>
-                    <a:lstStyle/>
-                    <a:p>
-                      <a:r>
-                        <a:rPr sz="1500" b="1">
-                          <a:solidFill>
-                            <a:srgbClr val="6B4DE6"/>
-                          </a:solidFill>
-                          <a:latin typeface="Calibri"/>
-                        </a:rPr>
-                        <a:t>Database</a:t>
-                      </a:r>
-                    </a:p>
-                  </a:txBody>
-                  <a:tcPr>
-                    <a:solidFill>
-                      <a:srgbClr val="ECE7FE"/>
-                    </a:solidFill>
-                  </a:tcPr>
-                </a:tc>
-                <a:tc>
-                  <a:txBody>
-                    <a:bodyPr lIns="109728" rIns="109728" tIns="36576" bIns="36576"/>
-                    <a:lstStyle/>
-                    <a:p>
-                      <a:r>
-                        <a:rPr sz="1500" b="0">
-                          <a:solidFill>
-                            <a:srgbClr val="1F2129"/>
-                          </a:solidFill>
-                          <a:latin typeface="Calibri"/>
-                        </a:rPr>
-                        <a:t>cloud_firestore  -  real-time queue, votes, chat</a:t>
-                      </a:r>
-                    </a:p>
-                  </a:txBody>
-                  <a:tcPr>
-                    <a:solidFill>
-                      <a:srgbClr val="FAFAFB"/>
-                    </a:solidFill>
-                  </a:tcPr>
-                </a:tc>
-              </a:tr>
-              <a:tr h="420624">
-                <a:tc>
-                  <a:txBody>
-                    <a:bodyPr lIns="109728" rIns="109728" tIns="36576" bIns="36576"/>
-                    <a:lstStyle/>
-                    <a:p>
-                      <a:r>
-                        <a:rPr sz="1500" b="1">
-                          <a:solidFill>
-                            <a:srgbClr val="6B4DE6"/>
-                          </a:solidFill>
-                          <a:latin typeface="Calibri"/>
-                        </a:rPr>
-                        <a:t>Files</a:t>
-                      </a:r>
-                    </a:p>
-                  </a:txBody>
-                  <a:tcPr>
-                    <a:solidFill>
-                      <a:srgbClr val="ECE7FE"/>
-                    </a:solidFill>
-                  </a:tcPr>
-                </a:tc>
-                <a:tc>
-                  <a:txBody>
-                    <a:bodyPr lIns="109728" rIns="109728" tIns="36576" bIns="36576"/>
-                    <a:lstStyle/>
-                    <a:p>
-                      <a:r>
-                        <a:rPr sz="1500" b="0">
-                          <a:solidFill>
-                            <a:srgbClr val="1F2129"/>
-                          </a:solidFill>
-                          <a:latin typeface="Calibri"/>
-                        </a:rPr>
-                        <a:t>firebase_storage  -  avatars</a:t>
-                      </a:r>
-                    </a:p>
-                  </a:txBody>
-                  <a:tcPr>
-                    <a:solidFill>
-                      <a:srgbClr val="FAFAFB"/>
-                    </a:solidFill>
-                  </a:tcPr>
-                </a:tc>
-              </a:tr>
-              <a:tr h="420624">
-                <a:tc>
-                  <a:txBody>
-                    <a:bodyPr lIns="109728" rIns="109728" tIns="36576" bIns="36576"/>
-                    <a:lstStyle/>
-                    <a:p>
-                      <a:r>
-                        <a:rPr sz="1500" b="1">
-                          <a:solidFill>
-                            <a:srgbClr val="6B4DE6"/>
-                          </a:solidFill>
-                          <a:latin typeface="Calibri"/>
-                        </a:rPr>
-                        <a:t>Push</a:t>
-                      </a:r>
-                    </a:p>
-                  </a:txBody>
-                  <a:tcPr>
-                    <a:solidFill>
-                      <a:srgbClr val="ECE7FE"/>
-                    </a:solidFill>
-                  </a:tcPr>
-                </a:tc>
-                <a:tc>
-                  <a:txBody>
-                    <a:bodyPr lIns="109728" rIns="109728" tIns="36576" bIns="36576"/>
-                    <a:lstStyle/>
-                    <a:p>
-                      <a:r>
-                        <a:rPr sz="1500" b="0">
-                          <a:solidFill>
-                            <a:srgbClr val="1F2129"/>
-                          </a:solidFill>
-                          <a:latin typeface="Calibri"/>
-                        </a:rPr>
-                        <a:t>firebase_messaging  -  invites, vote rounds</a:t>
-                      </a:r>
-                    </a:p>
-                  </a:txBody>
-                  <a:tcPr>
-                    <a:solidFill>
-                      <a:srgbClr val="FAFAFB"/>
-                    </a:solidFill>
-                  </a:tcPr>
-                </a:tc>
-              </a:tr>
-              <a:tr h="420624">
-                <a:tc>
-                  <a:txBody>
-                    <a:bodyPr lIns="109728" rIns="109728" tIns="36576" bIns="36576"/>
-                    <a:lstStyle/>
-                    <a:p>
-                      <a:r>
-                        <a:rPr sz="1500" b="1">
-                          <a:solidFill>
-                            <a:srgbClr val="6B4DE6"/>
-                          </a:solidFill>
-                          <a:latin typeface="Calibri"/>
-                        </a:rPr>
-                        <a:t>Server</a:t>
-                      </a:r>
-                    </a:p>
-                  </a:txBody>
-                  <a:tcPr>
-                    <a:solidFill>
-                      <a:srgbClr val="ECE7FE"/>
-                    </a:solidFill>
-                  </a:tcPr>
-                </a:tc>
-                <a:tc>
-                  <a:txBody>
-                    <a:bodyPr lIns="109728" rIns="109728" tIns="36576" bIns="36576"/>
-                    <a:lstStyle/>
-                    <a:p>
-                      <a:r>
-                        <a:rPr sz="1500" b="0">
-                          <a:solidFill>
-                            <a:srgbClr val="1F2129"/>
-                          </a:solidFill>
-                          <a:latin typeface="Calibri"/>
-                        </a:rPr>
-                        <a:t>cloud_functions (Node 22 / TS)  -  Spotify bridge, secrets</a:t>
-                      </a:r>
-                    </a:p>
-                  </a:txBody>
-                  <a:tcPr>
-                    <a:solidFill>
-                      <a:srgbClr val="FAFAFB"/>
-                    </a:solidFill>
-                  </a:tcPr>
-                </a:tc>
-              </a:tr>
-            </a:tbl>
-          </a:graphicData>
-        </a:graphic>
-      </p:graphicFrame>
+        </p:nvSpPr>
+        <p:spPr>
+          <a:xfrm>
+            <a:off x="502920" y="1691640"/>
+            <a:ext cx="11183112" cy="2806700"/>
+          </a:xfrm>
+          <a:prstGeom prst="rect">
+            <a:avLst/>
+          </a:prstGeom>
+          <a:noFill/>
+        </p:spPr>
+        <p:txBody>
+          <a:bodyPr wrap="square">
+            <a:spAutoFit/>
+          </a:bodyPr>
+          <a:lstStyle/>
+          <a:p>
+            <a:pPr algn="l">
+              <a:spcAft>
+                <a:spcPts val="600"/>
+              </a:spcAft>
+            </a:pPr>
+            <a:r>
+              <a:rPr sz="1800">
+                <a:solidFill>
+                  <a:srgbClr val="1F2129"/>
+                </a:solidFill>
+                <a:latin typeface="Calibri"/>
+              </a:rPr>
+              <a:t>Mobile app — Flutter (one codebase that works on Android phones)</a:t>
+            </a:r>
+          </a:p>
+          <a:p>
+            <a:pPr algn="l">
+              <a:spcAft>
+                <a:spcPts val="600"/>
+              </a:spcAft>
+            </a:pPr>
+            <a:r>
+              <a:rPr sz="1800">
+                <a:solidFill>
+                  <a:srgbClr val="1F2129"/>
+                </a:solidFill>
+                <a:latin typeface="Calibri"/>
+              </a:rPr>
+              <a:t>Keeps everything in sync — Riverpod (modern state management)</a:t>
+            </a:r>
+          </a:p>
+          <a:p>
+            <a:pPr algn="l">
+              <a:spcAft>
+                <a:spcPts val="600"/>
+              </a:spcAft>
+            </a:pPr>
+            <a:r>
+              <a:rPr sz="1800">
+                <a:solidFill>
+                  <a:srgbClr val="1F2129"/>
+                </a:solidFill>
+                <a:latin typeface="Calibri"/>
+              </a:rPr>
+              <a:t>Moving between screens — go_router (remembers if you're logged in)</a:t>
+            </a:r>
+          </a:p>
+          <a:p>
+            <a:pPr algn="l">
+              <a:spcAft>
+                <a:spcPts val="600"/>
+              </a:spcAft>
+            </a:pPr>
+            <a:r>
+              <a:rPr sz="1800">
+                <a:solidFill>
+                  <a:srgbClr val="1F2129"/>
+                </a:solidFill>
+                <a:latin typeface="Calibri"/>
+              </a:rPr>
+              <a:t>Login and user accounts — Firebase Authentication (email + password)</a:t>
+            </a:r>
+          </a:p>
+          <a:p>
+            <a:pPr algn="l">
+              <a:spcAft>
+                <a:spcPts val="600"/>
+              </a:spcAft>
+            </a:pPr>
+            <a:r>
+              <a:rPr sz="1800">
+                <a:solidFill>
+                  <a:srgbClr val="1F2129"/>
+                </a:solidFill>
+                <a:latin typeface="Calibri"/>
+              </a:rPr>
+              <a:t>Live shared playlist and chat — Cloud Firestore (updates appear instantly)</a:t>
+            </a:r>
+          </a:p>
+          <a:p>
+            <a:pPr algn="l">
+              <a:spcAft>
+                <a:spcPts val="600"/>
+              </a:spcAft>
+            </a:pPr>
+            <a:r>
+              <a:rPr sz="1800">
+                <a:solidFill>
+                  <a:srgbClr val="1F2129"/>
+                </a:solidFill>
+                <a:latin typeface="Calibri"/>
+              </a:rPr>
+              <a:t>Profile pictures — Firebase Storage</a:t>
+            </a:r>
+          </a:p>
+          <a:p>
+            <a:pPr algn="l">
+              <a:spcAft>
+                <a:spcPts val="600"/>
+              </a:spcAft>
+            </a:pPr>
+            <a:r>
+              <a:rPr sz="1800">
+                <a:solidFill>
+                  <a:srgbClr val="1F2129"/>
+                </a:solidFill>
+                <a:latin typeface="Calibri"/>
+              </a:rPr>
+              <a:t>Push notifications when friends vote or join — Firebase Cloud Messaging</a:t>
+            </a:r>
+          </a:p>
+          <a:p>
+            <a:pPr algn="l">
+              <a:spcAft>
+                <a:spcPts val="600"/>
+              </a:spcAft>
+            </a:pPr>
+            <a:r>
+              <a:rPr sz="1800">
+                <a:solidFill>
+                  <a:srgbClr val="1F2129"/>
+                </a:solidFill>
+                <a:latin typeface="Calibri"/>
+              </a:rPr>
+              <a:t>Searching Spotify without exposing secrets — Cloud Functions (the secret stays on the server)</a:t>
+            </a:r>
+          </a:p>
+        </p:txBody>
+      </p:sp>
     </p:spTree>
   </p:cSld>
   <p:clrMapOvr>
@@ -9590,7 +8760,7 @@
                 </a:solidFill>
                 <a:latin typeface="Calibri"/>
               </a:rPr>
-              <a:t>Build sequence: a staircase, not a pile</a:t>
+              <a:t>I built the hard parts in this order</a:t>
             </a:r>
           </a:p>
         </p:txBody>
@@ -9624,7 +8794,7 @@
                 </a:solidFill>
                 <a:latin typeface="Calibri"/>
               </a:rPr>
-              <a:t>Q1  -  Implementation</a:t>
+              <a:t>Q1 — Implementation</a:t>
             </a:r>
           </a:p>
         </p:txBody>
@@ -9673,7 +8843,7 @@
         <p:spPr>
           <a:xfrm>
             <a:off x="502920" y="1691640"/>
-            <a:ext cx="11183112" cy="1485900"/>
+            <a:ext cx="11183112" cy="2806700"/>
           </a:xfrm>
           <a:prstGeom prst="rect">
             <a:avLst/>
@@ -9698,7 +8868,7 @@
                 </a:solidFill>
                 <a:latin typeface="Calibri"/>
               </a:rPr>
-              <a:t>1.  Queue + voting   (auth + Firestore + transactions + rules together)</a:t>
+              <a:t>First: the shared playlist and voting system</a:t>
             </a:r>
           </a:p>
           <a:p>
@@ -9714,7 +8884,7 @@
                 </a:solidFill>
                 <a:latin typeface="Calibri"/>
               </a:rPr>
-              <a:t>2.  Spotify Cloud Function   (server tier; queue already accepts any source)</a:t>
+              <a:t>   - This tested login, the database, and security rules all at once</a:t>
             </a:r>
           </a:p>
           <a:p>
@@ -9730,7 +8900,7 @@
                 </a:solidFill>
                 <a:latin typeface="Calibri"/>
               </a:rPr>
-              <a:t>3.  Recommendations + fairness   (consume what 1 + 2 produced)</a:t>
+              <a:t>Second: the Spotify search (through a Cloud Function on the server)</a:t>
             </a:r>
           </a:p>
           <a:p>
@@ -9746,7 +8916,62 @@
                 </a:solidFill>
                 <a:latin typeface="Calibri"/>
               </a:rPr>
-              <a:t>Each layer had a tested predecessor before any new uncertainty was added</a:t>
+              <a:t>   - The playlist was already working, so I could test real songs safely</a:t>
+            </a:r>
+          </a:p>
+          <a:p>
+            <a:pPr algn="l">
+              <a:spcAft>
+                <a:spcPts val="600"/>
+              </a:spcAft>
+            </a:pPr>
+            <a:r>
+              <a:rPr sz="1800">
+                <a:solidFill>
+                  <a:srgbClr val="1F2129"/>
+                </a:solidFill>
+                <a:latin typeface="Calibri"/>
+              </a:rPr>
+              <a:t>Third: the AI song suggestions and fairness ranking</a:t>
+            </a:r>
+          </a:p>
+          <a:p>
+            <a:pPr algn="l">
+              <a:spcAft>
+                <a:spcPts val="600"/>
+              </a:spcAft>
+            </a:pPr>
+            <a:r>
+              <a:rPr sz="1800">
+                <a:solidFill>
+                  <a:srgbClr val="1F2129"/>
+                </a:solidFill>
+                <a:latin typeface="Calibri"/>
+              </a:rPr>
+              <a:t>   - These use the playlist data that was already solid</a:t>
+            </a:r>
+          </a:p>
+          <a:p>
+            <a:pPr algn="l">
+              <a:spcAft>
+                <a:spcPts val="600"/>
+              </a:spcAft>
+            </a:pPr>
+          </a:p>
+          <a:p>
+            <a:pPr algn="l">
+              <a:spcAft>
+                <a:spcPts val="600"/>
+              </a:spcAft>
+            </a:pPr>
+            <a:r>
+              <a:rPr sz="1800">
+                <a:solidFill>
+                  <a:srgbClr val="1F2129"/>
+                </a:solidFill>
+                <a:latin typeface="Calibri"/>
+              </a:rPr>
+              <a:t>Building this way meant each new feature had something that already worked underneath it.</a:t>
             </a:r>
           </a:p>
         </p:txBody>
@@ -9884,7 +9109,7 @@
                 </a:solidFill>
                 <a:latin typeface="Calibri"/>
               </a:rPr>
-              <a:t>Screen decomposition + auth-aware routing</a:t>
+              <a:t>I kept each screen simple and easy to follow</a:t>
             </a:r>
           </a:p>
         </p:txBody>
@@ -9918,7 +9143,7 @@
                 </a:solidFill>
                 <a:latin typeface="Calibri"/>
               </a:rPr>
-              <a:t>Q4 + Q5  -  Architecture</a:t>
+              <a:t>Q4 + Q5 — Architecture</a:t>
             </a:r>
           </a:p>
         </p:txBody>
@@ -9992,7 +9217,7 @@
                 </a:solidFill>
                 <a:latin typeface="Calibri"/>
               </a:rPr>
-              <a:t>SessionScreen (tab host)</a:t>
+              <a:t>The main session screen used to try to do everything at once (playlist, chat, suggestions)</a:t>
             </a:r>
           </a:p>
           <a:p>
@@ -10008,7 +9233,7 @@
                 </a:solidFill>
                 <a:latin typeface="Calibri"/>
               </a:rPr>
-              <a:t>    -  QueueTrackTile         (one row, owns vote state)</a:t>
+              <a:t>I split it into smaller pieces that each have one job:</a:t>
             </a:r>
           </a:p>
           <a:p>
@@ -10024,7 +9249,7 @@
                 </a:solidFill>
                 <a:latin typeface="Calibri"/>
               </a:rPr>
-              <a:t>    -  SuggestionsCard        (AI helper, decoupled from queue)</a:t>
+              <a:t>   • QueueTrackTile — shows one song and its vote buttons</a:t>
             </a:r>
           </a:p>
           <a:p>
@@ -10040,7 +9265,7 @@
                 </a:solidFill>
                 <a:latin typeface="Calibri"/>
               </a:rPr>
-              <a:t>    -  ChatScreen             (own route, survives backgrounding)</a:t>
+              <a:t>   • SuggestionsCard — shows the AI's next-song ideas with explanations</a:t>
             </a:r>
           </a:p>
           <a:p>
@@ -10056,7 +9281,7 @@
                 </a:solidFill>
                 <a:latin typeface="Calibri"/>
               </a:rPr>
-              <a:t>GoRouter with auth-aware redirect:</a:t>
+              <a:t>   • ChatScreen — its own page so you can switch away and come back</a:t>
             </a:r>
           </a:p>
           <a:p>
@@ -10065,6 +9290,13 @@
                 <a:spcPts val="600"/>
               </a:spcAft>
             </a:pPr>
+          </a:p>
+          <a:p>
+            <a:pPr algn="l">
+              <a:spcAft>
+                <a:spcPts val="600"/>
+              </a:spcAft>
+            </a:pPr>
             <a:r>
               <a:rPr sz="1800">
                 <a:solidFill>
@@ -10072,7 +9304,7 @@
                 </a:solidFill>
                 <a:latin typeface="Calibri"/>
               </a:rPr>
-              <a:t>    -  signed-out + private route  -&gt; /sign-in</a:t>
+              <a:t>Navigation remembers whether you're logged in and sends you to the right place automatically.</a:t>
             </a:r>
           </a:p>
           <a:p>
@@ -10088,23 +9320,7 @@
                 </a:solidFill>
                 <a:latin typeface="Calibri"/>
               </a:rPr>
-              <a:t>    -  signed-in  + auth screen   -&gt; /</a:t>
-            </a:r>
-          </a:p>
-          <a:p>
-            <a:pPr algn="l">
-              <a:spcAft>
-                <a:spcPts val="600"/>
-              </a:spcAft>
-            </a:pPr>
-            <a:r>
-              <a:rPr sz="1800">
-                <a:solidFill>
-                  <a:srgbClr val="1F2129"/>
-                </a:solidFill>
-                <a:latin typeface="Calibri"/>
-              </a:rPr>
-              <a:t>    -  zero changes to add a new private route</a:t>
+              <a:t>Adding a new screen later is just one line of code.</a:t>
             </a:r>
           </a:p>
         </p:txBody>
@@ -10242,7 +9458,7 @@
                 </a:solidFill>
                 <a:latin typeface="Calibri"/>
               </a:rPr>
-              <a:t>Firestore data model</a:t>
+              <a:t>How the data is organized</a:t>
             </a:r>
           </a:p>
         </p:txBody>
@@ -10276,7 +9492,7 @@
                 </a:solidFill>
                 <a:latin typeface="Calibri"/>
               </a:rPr>
-              <a:t>Q10  -  Firebase</a:t>
+              <a:t>Q10 — Firebase</a:t>
             </a:r>
           </a:p>
         </p:txBody>
@@ -10318,170 +9534,14 @@
       </p:cxnSp>
       <p:sp>
         <p:nvSpPr>
-          <p:cNvPr id="7" name="Rounded Rectangle 6"/>
-          <p:cNvSpPr/>
-          <p:nvPr/>
-        </p:nvSpPr>
-        <p:spPr>
-          <a:xfrm>
-            <a:off x="502920" y="1691640"/>
-            <a:ext cx="11183112" cy="1614169"/>
-          </a:xfrm>
-          <a:prstGeom prst="roundRect">
-            <a:avLst>
-              <a:gd name="adj" fmla="val 4000"/>
-            </a:avLst>
-          </a:prstGeom>
-          <a:solidFill>
-            <a:srgbClr val="F1F2F6"/>
-          </a:solidFill>
-          <a:ln w="6350">
-            <a:solidFill>
-              <a:srgbClr val="E5E7EB"/>
-            </a:solidFill>
-          </a:ln>
-        </p:spPr>
-        <p:style>
-          <a:lnRef idx="1">
-            <a:schemeClr val="accent1"/>
-          </a:lnRef>
-          <a:fillRef idx="3">
-            <a:schemeClr val="accent1"/>
-          </a:fillRef>
-          <a:effectRef idx="2">
-            <a:schemeClr val="accent1"/>
-          </a:effectRef>
-          <a:fontRef idx="minor">
-            <a:schemeClr val="lt1"/>
-          </a:fontRef>
-        </p:style>
-        <p:txBody>
-          <a:bodyPr rtlCol="0" anchor="ctr" wrap="none" lIns="164592" rIns="164592" tIns="73152" bIns="73152"/>
-          <a:lstStyle/>
-          <a:p>
-            <a:pPr algn="l">
-              <a:spcAft>
-                <a:spcPts val="0"/>
-              </a:spcAft>
-            </a:pPr>
-            <a:r>
-              <a:rPr sz="1300">
-                <a:solidFill>
-                  <a:srgbClr val="1F2129"/>
-                </a:solidFill>
-                <a:latin typeface="Consolas"/>
-              </a:rPr>
-              <a:t>users/{uid}</a:t>
-            </a:r>
-          </a:p>
-          <a:p>
-            <a:pPr algn="l">
-              <a:spcAft>
-                <a:spcPts val="0"/>
-              </a:spcAft>
-            </a:pPr>
-            <a:r>
-              <a:rPr sz="1300">
-                <a:solidFill>
-                  <a:srgbClr val="1F2129"/>
-                </a:solidFill>
-                <a:latin typeface="Consolas"/>
-              </a:rPr>
-              <a:t>sessions/{sessionId}</a:t>
-            </a:r>
-          </a:p>
-          <a:p>
-            <a:pPr algn="l">
-              <a:spcAft>
-                <a:spcPts val="0"/>
-              </a:spcAft>
-            </a:pPr>
-            <a:r>
-              <a:rPr sz="1300">
-                <a:solidFill>
-                  <a:srgbClr val="1F2129"/>
-                </a:solidFill>
-                <a:latin typeface="Consolas"/>
-              </a:rPr>
-              <a:t>  |-- members/{uid}</a:t>
-            </a:r>
-          </a:p>
-          <a:p>
-            <a:pPr algn="l">
-              <a:spcAft>
-                <a:spcPts val="0"/>
-              </a:spcAft>
-            </a:pPr>
-            <a:r>
-              <a:rPr sz="1300">
-                <a:solidFill>
-                  <a:srgbClr val="1F2129"/>
-                </a:solidFill>
-                <a:latin typeface="Consolas"/>
-              </a:rPr>
-              <a:t>  |-- queue/{trackId}</a:t>
-            </a:r>
-          </a:p>
-          <a:p>
-            <a:pPr algn="l">
-              <a:spcAft>
-                <a:spcPts val="0"/>
-              </a:spcAft>
-            </a:pPr>
-            <a:r>
-              <a:rPr sz="1300">
-                <a:solidFill>
-                  <a:srgbClr val="1F2129"/>
-                </a:solidFill>
-                <a:latin typeface="Consolas"/>
-              </a:rPr>
-              <a:t>  |-- messages/{messageId}</a:t>
-            </a:r>
-          </a:p>
-          <a:p>
-            <a:pPr algn="l">
-              <a:spcAft>
-                <a:spcPts val="0"/>
-              </a:spcAft>
-            </a:pPr>
-            <a:r>
-              <a:rPr sz="1300">
-                <a:solidFill>
-                  <a:srgbClr val="1F2129"/>
-                </a:solidFill>
-                <a:latin typeface="Consolas"/>
-              </a:rPr>
-              <a:t>  +-- suggestions/{snapshotId}</a:t>
-            </a:r>
-          </a:p>
-          <a:p>
-            <a:pPr algn="l">
-              <a:spcAft>
-                <a:spcPts val="0"/>
-              </a:spcAft>
-            </a:pPr>
-            <a:r>
-              <a:rPr sz="1300">
-                <a:solidFill>
-                  <a:srgbClr val="1F2129"/>
-                </a:solidFill>
-                <a:latin typeface="Consolas"/>
-              </a:rPr>
-              <a:t>joinCodes/{code}      &lt;-- public lookup (read-only mapping)</a:t>
-            </a:r>
-          </a:p>
-        </p:txBody>
-      </p:sp>
-      <p:sp>
-        <p:nvSpPr>
-          <p:cNvPr id="8" name="TextBox 7"/>
+          <p:cNvPr id="7" name="TextBox 6"/>
           <p:cNvSpPr txBox="1"/>
           <p:nvPr/>
         </p:nvSpPr>
         <p:spPr>
           <a:xfrm>
-            <a:off x="502920" y="3442969"/>
-            <a:ext cx="11183112" cy="1155700"/>
+            <a:off x="502920" y="1691640"/>
+            <a:ext cx="11183112" cy="3136900"/>
           </a:xfrm>
           <a:prstGeom prst="rect">
             <a:avLst/>
@@ -10506,7 +9566,7 @@
                 </a:solidFill>
                 <a:latin typeface="Calibri"/>
               </a:rPr>
-              <a:t>Subcollections under sessions: one rule call (isSessionMember) per request, not per doc</a:t>
+              <a:t>Three main collections:</a:t>
             </a:r>
           </a:p>
           <a:p>
@@ -10522,7 +9582,7 @@
                 </a:solidFill>
                 <a:latin typeface="Calibri"/>
               </a:rPr>
-              <a:t>Riverpod listener teardown is automatic when navigating out of a session</a:t>
+              <a:t>   • users — profile pictures and preferences</a:t>
             </a:r>
           </a:p>
           <a:p>
@@ -10538,7 +9598,85 @@
                 </a:solidFill>
                 <a:latin typeface="Calibri"/>
               </a:rPr>
-              <a:t>joinCodes is deliberately top-level + public so non-members can resolve a code first</a:t>
+              <a:t>   • sessions — the playlist room itself (title, owner, who is in it)</a:t>
+            </a:r>
+          </a:p>
+          <a:p>
+            <a:pPr algn="l">
+              <a:spcAft>
+                <a:spcPts val="600"/>
+              </a:spcAft>
+            </a:pPr>
+            <a:r>
+              <a:rPr sz="1800">
+                <a:solidFill>
+                  <a:srgbClr val="1F2129"/>
+                </a:solidFill>
+                <a:latin typeface="Calibri"/>
+              </a:rPr>
+              <a:t>   • joinCodes — a simple lookup so friends can join with a 6-letter code</a:t>
+            </a:r>
+          </a:p>
+          <a:p>
+            <a:pPr algn="l">
+              <a:spcAft>
+                <a:spcPts val="600"/>
+              </a:spcAft>
+            </a:pPr>
+          </a:p>
+          <a:p>
+            <a:pPr algn="l">
+              <a:spcAft>
+                <a:spcPts val="600"/>
+              </a:spcAft>
+            </a:pPr>
+            <a:r>
+              <a:rPr sz="1800">
+                <a:solidFill>
+                  <a:srgbClr val="1F2129"/>
+                </a:solidFill>
+                <a:latin typeface="Calibri"/>
+              </a:rPr>
+              <a:t>Inside each session there are smaller lists:</a:t>
+            </a:r>
+          </a:p>
+          <a:p>
+            <a:pPr algn="l">
+              <a:spcAft>
+                <a:spcPts val="600"/>
+              </a:spcAft>
+            </a:pPr>
+            <a:r>
+              <a:rPr sz="1800">
+                <a:solidFill>
+                  <a:srgbClr val="1F2129"/>
+                </a:solidFill>
+                <a:latin typeface="Calibri"/>
+              </a:rPr>
+              <a:t>   • members, queue (the songs), messages (chat), and suggestions (AI ideas)</a:t>
+            </a:r>
+          </a:p>
+          <a:p>
+            <a:pPr algn="l">
+              <a:spcAft>
+                <a:spcPts val="600"/>
+              </a:spcAft>
+            </a:pPr>
+          </a:p>
+          <a:p>
+            <a:pPr algn="l">
+              <a:spcAft>
+                <a:spcPts val="600"/>
+              </a:spcAft>
+            </a:pPr>
+            <a:r>
+              <a:rPr sz="1800">
+                <a:solidFill>
+                  <a:srgbClr val="1F2129"/>
+                </a:solidFill>
+                <a:latin typeface="Calibri"/>
+              </a:rPr>
+              <a:t>This structure makes the security rules simple and the screens fast — when you leave a session, everything cleans up automatically.</a:t>
             </a:r>
           </a:p>
         </p:txBody>
@@ -10676,7 +9814,7 @@
                 </a:solidFill>
                 <a:latin typeface="Calibri"/>
               </a:rPr>
-              <a:t>Join-by-code: the chicken-and-egg + the fix</a:t>
+              <a:t>The join-by-code problem (and how I fixed it)</a:t>
             </a:r>
           </a:p>
         </p:txBody>
@@ -10710,7 +9848,7 @@
                 </a:solidFill>
                 <a:latin typeface="Calibri"/>
               </a:rPr>
-              <a:t>Q14 + Q6  -  Reflection + Architecture</a:t>
+              <a:t>Q14 + Q6 — Reflection + Architecture</a:t>
             </a:r>
           </a:p>
         </p:txBody>
@@ -10759,7 +9897,7 @@
         <p:spPr>
           <a:xfrm>
             <a:off x="502920" y="1691640"/>
-            <a:ext cx="11183112" cy="825500"/>
+            <a:ext cx="11183112" cy="2476500"/>
           </a:xfrm>
           <a:prstGeom prst="rect">
             <a:avLst/>
@@ -10784,7 +9922,7 @@
                 </a:solidFill>
                 <a:latin typeface="Calibri"/>
               </a:rPr>
-              <a:t>v1 (broken):  sessions where code == ?      requires read on entire collection</a:t>
+              <a:t>Early version: to join you had to be able to see every session — that broke the privacy rules</a:t>
             </a:r>
           </a:p>
           <a:p>
@@ -10800,188 +9938,9 @@
                 </a:solidFill>
                 <a:latin typeface="Calibri"/>
               </a:rPr>
-              <a:t>v2 (shipped): joinCodes/{code} -&gt; sessionId   plus this rule:</a:t>
-            </a:r>
-          </a:p>
-        </p:txBody>
-      </p:sp>
-      <p:sp>
-        <p:nvSpPr>
-          <p:cNvPr id="8" name="Rounded Rectangle 7"/>
-          <p:cNvSpPr/>
-          <p:nvPr/>
-        </p:nvSpPr>
-        <p:spPr>
-          <a:xfrm>
-            <a:off x="502920" y="2562860"/>
-            <a:ext cx="11183112" cy="1614169"/>
-          </a:xfrm>
-          <a:prstGeom prst="roundRect">
-            <a:avLst>
-              <a:gd name="adj" fmla="val 4000"/>
-            </a:avLst>
-          </a:prstGeom>
-          <a:solidFill>
-            <a:srgbClr val="F1F2F6"/>
-          </a:solidFill>
-          <a:ln w="6350">
-            <a:solidFill>
-              <a:srgbClr val="E5E7EB"/>
-            </a:solidFill>
-          </a:ln>
-        </p:spPr>
-        <p:style>
-          <a:lnRef idx="1">
-            <a:schemeClr val="accent1"/>
-          </a:lnRef>
-          <a:fillRef idx="3">
-            <a:schemeClr val="accent1"/>
-          </a:fillRef>
-          <a:effectRef idx="2">
-            <a:schemeClr val="accent1"/>
-          </a:effectRef>
-          <a:fontRef idx="minor">
-            <a:schemeClr val="lt1"/>
-          </a:fontRef>
-        </p:style>
-        <p:txBody>
-          <a:bodyPr rtlCol="0" anchor="ctr" wrap="none" lIns="164592" rIns="164592" tIns="73152" bIns="73152"/>
-          <a:lstStyle/>
-          <a:p>
-            <a:pPr algn="l">
-              <a:spcAft>
-                <a:spcPts val="0"/>
-              </a:spcAft>
-            </a:pPr>
-            <a:r>
-              <a:rPr sz="1300">
-                <a:solidFill>
-                  <a:srgbClr val="1F2129"/>
-                </a:solidFill>
-                <a:latin typeface="Consolas"/>
-              </a:rPr>
-              <a:t>function isJoiningSelf() {</a:t>
-            </a:r>
-          </a:p>
-          <a:p>
-            <a:pPr algn="l">
-              <a:spcAft>
-                <a:spcPts val="0"/>
-              </a:spcAft>
-            </a:pPr>
-            <a:r>
-              <a:rPr sz="1300">
-                <a:solidFill>
-                  <a:srgbClr val="1F2129"/>
-                </a:solidFill>
-                <a:latin typeface="Consolas"/>
-              </a:rPr>
-              <a:t>  return isSignedIn()</a:t>
-            </a:r>
-          </a:p>
-          <a:p>
-            <a:pPr algn="l">
-              <a:spcAft>
-                <a:spcPts val="0"/>
-              </a:spcAft>
-            </a:pPr>
-            <a:r>
-              <a:rPr sz="1300">
-                <a:solidFill>
-                  <a:srgbClr val="1F2129"/>
-                </a:solidFill>
-                <a:latin typeface="Consolas"/>
-              </a:rPr>
-              <a:t>    &amp;&amp; !(request.auth.uid in resource.data.memberIds)</a:t>
-            </a:r>
-          </a:p>
-          <a:p>
-            <a:pPr algn="l">
-              <a:spcAft>
-                <a:spcPts val="0"/>
-              </a:spcAft>
-            </a:pPr>
-            <a:r>
-              <a:rPr sz="1300">
-                <a:solidFill>
-                  <a:srgbClr val="1F2129"/>
-                </a:solidFill>
-                <a:latin typeface="Consolas"/>
-              </a:rPr>
-              <a:t>    &amp;&amp; request.auth.uid in request.resource.data.memberIds</a:t>
-            </a:r>
-          </a:p>
-          <a:p>
-            <a:pPr algn="l">
-              <a:spcAft>
-                <a:spcPts val="0"/>
-              </a:spcAft>
-            </a:pPr>
-            <a:r>
-              <a:rPr sz="1300">
-                <a:solidFill>
-                  <a:srgbClr val="1F2129"/>
-                </a:solidFill>
-                <a:latin typeface="Consolas"/>
-              </a:rPr>
-              <a:t>    &amp;&amp; request.resource.data.diff(resource.data).affectedKeys()</a:t>
-            </a:r>
-          </a:p>
-          <a:p>
-            <a:pPr algn="l">
-              <a:spcAft>
-                <a:spcPts val="0"/>
-              </a:spcAft>
-            </a:pPr>
-            <a:r>
-              <a:rPr sz="1300">
-                <a:solidFill>
-                  <a:srgbClr val="1F2129"/>
-                </a:solidFill>
-                <a:latin typeface="Consolas"/>
-              </a:rPr>
-              <a:t>        .hasOnly(['memberIds', 'memberCount', 'updatedAt']);</a:t>
-            </a:r>
-          </a:p>
-          <a:p>
-            <a:pPr algn="l">
-              <a:spcAft>
-                <a:spcPts val="0"/>
-              </a:spcAft>
-            </a:pPr>
-            <a:r>
-              <a:rPr sz="1300">
-                <a:solidFill>
-                  <a:srgbClr val="1F2129"/>
-                </a:solidFill>
-                <a:latin typeface="Consolas"/>
-              </a:rPr>
-              <a:t>}</a:t>
-            </a:r>
-          </a:p>
-        </p:txBody>
-      </p:sp>
-      <p:sp>
-        <p:nvSpPr>
-          <p:cNvPr id="9" name="TextBox 8"/>
-          <p:cNvSpPr txBox="1"/>
-          <p:nvPr/>
-        </p:nvSpPr>
-        <p:spPr>
-          <a:xfrm>
-            <a:off x="502920" y="4314189"/>
-            <a:ext cx="11183112" cy="825500"/>
-          </a:xfrm>
-          <a:prstGeom prst="rect">
-            <a:avLst/>
-          </a:prstGeom>
-          <a:noFill/>
-        </p:spPr>
-        <p:txBody>
-          <a:bodyPr wrap="square">
-            <a:spAutoFit/>
-          </a:bodyPr>
-          <a:lstStyle/>
+              <a:t>Solution:</a:t>
+            </a:r>
+          </a:p>
           <a:p>
             <a:pPr algn="l">
               <a:spcAft>
@@ -10995,7 +9954,7 @@
                 </a:solidFill>
                 <a:latin typeface="Calibri"/>
               </a:rPr>
-              <a:t>Strict whitelist: a non-member can ONLY add their own UID + bump counters</a:t>
+              <a:t>   1. A small public lookup table (joinCodes) that anyone logged in can read</a:t>
             </a:r>
           </a:p>
           <a:p>
@@ -11011,7 +9970,46 @@
                 </a:solidFill>
                 <a:latin typeface="Calibri"/>
               </a:rPr>
-              <a:t>Pattern is now my default for any 'share-by-link' flow</a:t>
+              <a:t>   2. A special rule that lets a new person add ONLY themselves to the member list</a:t>
+            </a:r>
+          </a:p>
+          <a:p>
+            <a:pPr algn="l">
+              <a:spcAft>
+                <a:spcPts val="600"/>
+              </a:spcAft>
+            </a:pPr>
+          </a:p>
+          <a:p>
+            <a:pPr algn="l">
+              <a:spcAft>
+                <a:spcPts val="600"/>
+              </a:spcAft>
+            </a:pPr>
+            <a:r>
+              <a:rPr sz="1800">
+                <a:solidFill>
+                  <a:srgbClr val="1F2129"/>
+                </a:solidFill>
+                <a:latin typeface="Calibri"/>
+              </a:rPr>
+              <a:t>This pattern is now my go-to whenever I need a 'share this link' feature.</a:t>
+            </a:r>
+          </a:p>
+          <a:p>
+            <a:pPr algn="l">
+              <a:spcAft>
+                <a:spcPts val="600"/>
+              </a:spcAft>
+            </a:pPr>
+            <a:r>
+              <a:rPr sz="1800">
+                <a:solidFill>
+                  <a:srgbClr val="1F2129"/>
+                </a:solidFill>
+                <a:latin typeface="Calibri"/>
+              </a:rPr>
+              <a:t>It was the hardest bug I fixed — see Bug 2 in the bug log.</a:t>
             </a:r>
           </a:p>
         </p:txBody>
@@ -11149,7 +10147,7 @@
                 </a:solidFill>
                 <a:latin typeface="Calibri"/>
               </a:rPr>
-              <a:t>Composite index + read-cost trade-off</a:t>
+              <a:t>Making the home screen fast again</a:t>
             </a:r>
           </a:p>
         </p:txBody>
@@ -11183,7 +10181,7 @@
                 </a:solidFill>
                 <a:latin typeface="Calibri"/>
               </a:rPr>
-              <a:t>Q11  -  Firebase</a:t>
+              <a:t>Q11 — Firebase</a:t>
             </a:r>
           </a:p>
         </p:txBody>
@@ -11232,7 +10230,7 @@
         <p:spPr>
           <a:xfrm>
             <a:off x="502920" y="1691640"/>
-            <a:ext cx="11183112" cy="495300"/>
+            <a:ext cx="11183112" cy="2146300"/>
           </a:xfrm>
           <a:prstGeom prst="rect">
             <a:avLst/>
@@ -11257,140 +10255,9 @@
                 </a:solidFill>
                 <a:latin typeface="Calibri"/>
               </a:rPr>
-              <a:t>The query (home screen 'sessions I'm in'):</a:t>
-            </a:r>
-          </a:p>
-        </p:txBody>
-      </p:sp>
-      <p:sp>
-        <p:nvSpPr>
-          <p:cNvPr id="8" name="Rounded Rectangle 7"/>
-          <p:cNvSpPr/>
-          <p:nvPr/>
-        </p:nvSpPr>
-        <p:spPr>
-          <a:xfrm>
-            <a:off x="502920" y="2232660"/>
-            <a:ext cx="11183112" cy="1023620"/>
-          </a:xfrm>
-          <a:prstGeom prst="roundRect">
-            <a:avLst>
-              <a:gd name="adj" fmla="val 4000"/>
-            </a:avLst>
-          </a:prstGeom>
-          <a:solidFill>
-            <a:srgbClr val="F1F2F6"/>
-          </a:solidFill>
-          <a:ln w="6350">
-            <a:solidFill>
-              <a:srgbClr val="E5E7EB"/>
-            </a:solidFill>
-          </a:ln>
-        </p:spPr>
-        <p:style>
-          <a:lnRef idx="1">
-            <a:schemeClr val="accent1"/>
-          </a:lnRef>
-          <a:fillRef idx="3">
-            <a:schemeClr val="accent1"/>
-          </a:fillRef>
-          <a:effectRef idx="2">
-            <a:schemeClr val="accent1"/>
-          </a:effectRef>
-          <a:fontRef idx="minor">
-            <a:schemeClr val="lt1"/>
-          </a:fontRef>
-        </p:style>
-        <p:txBody>
-          <a:bodyPr rtlCol="0" anchor="ctr" wrap="none" lIns="164592" rIns="164592" tIns="73152" bIns="73152"/>
-          <a:lstStyle/>
-          <a:p>
-            <a:pPr algn="l">
-              <a:spcAft>
-                <a:spcPts val="0"/>
-              </a:spcAft>
-            </a:pPr>
-            <a:r>
-              <a:rPr sz="1300">
-                <a:solidFill>
-                  <a:srgbClr val="1F2129"/>
-                </a:solidFill>
-                <a:latin typeface="Consolas"/>
-              </a:rPr>
-              <a:t>_sessions</a:t>
-            </a:r>
-          </a:p>
-          <a:p>
-            <a:pPr algn="l">
-              <a:spcAft>
-                <a:spcPts val="0"/>
-              </a:spcAft>
-            </a:pPr>
-            <a:r>
-              <a:rPr sz="1300">
-                <a:solidFill>
-                  <a:srgbClr val="1F2129"/>
-                </a:solidFill>
-                <a:latin typeface="Consolas"/>
-              </a:rPr>
-              <a:t>    .where('memberIds', arrayContains: uid)</a:t>
-            </a:r>
-          </a:p>
-          <a:p>
-            <a:pPr algn="l">
-              <a:spcAft>
-                <a:spcPts val="0"/>
-              </a:spcAft>
-            </a:pPr>
-            <a:r>
-              <a:rPr sz="1300">
-                <a:solidFill>
-                  <a:srgbClr val="1F2129"/>
-                </a:solidFill>
-                <a:latin typeface="Consolas"/>
-              </a:rPr>
-              <a:t>    .orderBy('updatedAt', descending: true)</a:t>
-            </a:r>
-          </a:p>
-          <a:p>
-            <a:pPr algn="l">
-              <a:spcAft>
-                <a:spcPts val="0"/>
-              </a:spcAft>
-            </a:pPr>
-            <a:r>
-              <a:rPr sz="1300">
-                <a:solidFill>
-                  <a:srgbClr val="1F2129"/>
-                </a:solidFill>
-                <a:latin typeface="Consolas"/>
-              </a:rPr>
-              <a:t>    .snapshots();</a:t>
-            </a:r>
-          </a:p>
-        </p:txBody>
-      </p:sp>
-      <p:sp>
-        <p:nvSpPr>
-          <p:cNvPr id="9" name="TextBox 8"/>
-          <p:cNvSpPr txBox="1"/>
-          <p:nvPr/>
-        </p:nvSpPr>
-        <p:spPr>
-          <a:xfrm>
-            <a:off x="502920" y="3393440"/>
-            <a:ext cx="11183112" cy="495300"/>
-          </a:xfrm>
-          <a:prstGeom prst="rect">
-            <a:avLst/>
-          </a:prstGeom>
-          <a:noFill/>
-        </p:spPr>
-        <p:txBody>
-          <a:bodyPr wrap="square">
-            <a:spAutoFit/>
-          </a:bodyPr>
-          <a:lstStyle/>
+              <a:t>The home screen asks: 'show me all the sessions I'm part of, newest first'</a:t>
+            </a:r>
+          </a:p>
           <a:p>
             <a:pPr algn="l">
               <a:spcAft>
@@ -11404,188 +10271,9 @@
                 </a:solidFill>
                 <a:latin typeface="Calibri"/>
               </a:rPr>
-              <a:t>The required composite index, declared in firestore.indexes.json:</a:t>
-            </a:r>
-          </a:p>
-        </p:txBody>
-      </p:sp>
-      <p:sp>
-        <p:nvSpPr>
-          <p:cNvPr id="10" name="Rounded Rectangle 9"/>
-          <p:cNvSpPr/>
-          <p:nvPr/>
-        </p:nvSpPr>
-        <p:spPr>
-          <a:xfrm>
-            <a:off x="502920" y="3934460"/>
-            <a:ext cx="11183112" cy="1614169"/>
-          </a:xfrm>
-          <a:prstGeom prst="roundRect">
-            <a:avLst>
-              <a:gd name="adj" fmla="val 4000"/>
-            </a:avLst>
-          </a:prstGeom>
-          <a:solidFill>
-            <a:srgbClr val="F1F2F6"/>
-          </a:solidFill>
-          <a:ln w="6350">
-            <a:solidFill>
-              <a:srgbClr val="E5E7EB"/>
-            </a:solidFill>
-          </a:ln>
-        </p:spPr>
-        <p:style>
-          <a:lnRef idx="1">
-            <a:schemeClr val="accent1"/>
-          </a:lnRef>
-          <a:fillRef idx="3">
-            <a:schemeClr val="accent1"/>
-          </a:fillRef>
-          <a:effectRef idx="2">
-            <a:schemeClr val="accent1"/>
-          </a:effectRef>
-          <a:fontRef idx="minor">
-            <a:schemeClr val="lt1"/>
-          </a:fontRef>
-        </p:style>
-        <p:txBody>
-          <a:bodyPr rtlCol="0" anchor="ctr" wrap="none" lIns="164592" rIns="164592" tIns="73152" bIns="73152"/>
-          <a:lstStyle/>
-          <a:p>
-            <a:pPr algn="l">
-              <a:spcAft>
-                <a:spcPts val="0"/>
-              </a:spcAft>
-            </a:pPr>
-            <a:r>
-              <a:rPr sz="1300">
-                <a:solidFill>
-                  <a:srgbClr val="1F2129"/>
-                </a:solidFill>
-                <a:latin typeface="Consolas"/>
-              </a:rPr>
-              <a:t>{</a:t>
-            </a:r>
-          </a:p>
-          <a:p>
-            <a:pPr algn="l">
-              <a:spcAft>
-                <a:spcPts val="0"/>
-              </a:spcAft>
-            </a:pPr>
-            <a:r>
-              <a:rPr sz="1300">
-                <a:solidFill>
-                  <a:srgbClr val="1F2129"/>
-                </a:solidFill>
-                <a:latin typeface="Consolas"/>
-              </a:rPr>
-              <a:t>  "collectionGroup": "sessions",</a:t>
-            </a:r>
-          </a:p>
-          <a:p>
-            <a:pPr algn="l">
-              <a:spcAft>
-                <a:spcPts val="0"/>
-              </a:spcAft>
-            </a:pPr>
-            <a:r>
-              <a:rPr sz="1300">
-                <a:solidFill>
-                  <a:srgbClr val="1F2129"/>
-                </a:solidFill>
-                <a:latin typeface="Consolas"/>
-              </a:rPr>
-              <a:t>  "fields": [</a:t>
-            </a:r>
-          </a:p>
-          <a:p>
-            <a:pPr algn="l">
-              <a:spcAft>
-                <a:spcPts val="0"/>
-              </a:spcAft>
-            </a:pPr>
-            <a:r>
-              <a:rPr sz="1300">
-                <a:solidFill>
-                  <a:srgbClr val="1F2129"/>
-                </a:solidFill>
-                <a:latin typeface="Consolas"/>
-              </a:rPr>
-              <a:t>    { "fieldPath": "memberIds", "arrayConfig": "CONTAINS" },</a:t>
-            </a:r>
-          </a:p>
-          <a:p>
-            <a:pPr algn="l">
-              <a:spcAft>
-                <a:spcPts val="0"/>
-              </a:spcAft>
-            </a:pPr>
-            <a:r>
-              <a:rPr sz="1300">
-                <a:solidFill>
-                  <a:srgbClr val="1F2129"/>
-                </a:solidFill>
-                <a:latin typeface="Consolas"/>
-              </a:rPr>
-              <a:t>    { "fieldPath": "updatedAt", "order": "DESCENDING" }</a:t>
-            </a:r>
-          </a:p>
-          <a:p>
-            <a:pPr algn="l">
-              <a:spcAft>
-                <a:spcPts val="0"/>
-              </a:spcAft>
-            </a:pPr>
-            <a:r>
-              <a:rPr sz="1300">
-                <a:solidFill>
-                  <a:srgbClr val="1F2129"/>
-                </a:solidFill>
-                <a:latin typeface="Consolas"/>
-              </a:rPr>
-              <a:t>  ]</a:t>
-            </a:r>
-          </a:p>
-          <a:p>
-            <a:pPr algn="l">
-              <a:spcAft>
-                <a:spcPts val="0"/>
-              </a:spcAft>
-            </a:pPr>
-            <a:r>
-              <a:rPr sz="1300">
-                <a:solidFill>
-                  <a:srgbClr val="1F2129"/>
-                </a:solidFill>
-                <a:latin typeface="Consolas"/>
-              </a:rPr>
-              <a:t>}</a:t>
-            </a:r>
-          </a:p>
-        </p:txBody>
-      </p:sp>
-      <p:sp>
-        <p:nvSpPr>
-          <p:cNvPr id="11" name="TextBox 10"/>
-          <p:cNvSpPr txBox="1"/>
-          <p:nvPr/>
-        </p:nvSpPr>
-        <p:spPr>
-          <a:xfrm>
-            <a:off x="502920" y="5685789"/>
-            <a:ext cx="11183112" cy="825500"/>
-          </a:xfrm>
-          <a:prstGeom prst="rect">
-            <a:avLst/>
-          </a:prstGeom>
-          <a:noFill/>
-        </p:spPr>
-        <p:txBody>
-          <a:bodyPr wrap="square">
-            <a:spAutoFit/>
-          </a:bodyPr>
-          <a:lstStyle/>
+              <a:t>That combination of filters needs a special index in the database</a:t>
+            </a:r>
+          </a:p>
           <a:p>
             <a:pPr algn="l">
               <a:spcAft>
@@ -11599,7 +10287,7 @@
                 </a:solidFill>
                 <a:latin typeface="Calibri"/>
               </a:rPr>
-              <a:t>Write-amplifying:  N members  -&gt;  N index entries per updatedAt bump</a:t>
+              <a:t>I added it to a file called firestore.indexes.json so it gets deployed automatically</a:t>
             </a:r>
           </a:p>
           <a:p>
@@ -11608,6 +10296,13 @@
                 <a:spcPts val="600"/>
               </a:spcAft>
             </a:pPr>
+          </a:p>
+          <a:p>
+            <a:pPr algn="l">
+              <a:spcAft>
+                <a:spcPts val="600"/>
+              </a:spcAft>
+            </a:pPr>
             <a:r>
               <a:rPr sz="1800">
                 <a:solidFill>
@@ -11615,7 +10310,23 @@
                 </a:solidFill>
                 <a:latin typeface="Calibri"/>
               </a:rPr>
-              <a:t>50-member cap keeps every session well under Firestore's 40 KiB index budget</a:t>
+              <a:t>Without it the screen would spin forever. With it the list appears in under 200 milliseconds.</a:t>
+            </a:r>
+          </a:p>
+          <a:p>
+            <a:pPr algn="l">
+              <a:spcAft>
+                <a:spcPts val="600"/>
+              </a:spcAft>
+            </a:pPr>
+            <a:r>
+              <a:rPr sz="1800">
+                <a:solidFill>
+                  <a:srgbClr val="1F2129"/>
+                </a:solidFill>
+                <a:latin typeface="Calibri"/>
+              </a:rPr>
+              <a:t>Same fix was needed for the playlist view once we started hiding played songs.</a:t>
             </a:r>
           </a:p>
         </p:txBody>
@@ -11753,7 +10464,7 @@
                 </a:solidFill>
                 <a:latin typeface="Calibri"/>
               </a:rPr>
-              <a:t>Auth-scoped rule: users can only touch themselves</a:t>
+              <a:t>Only you can edit your own profile</a:t>
             </a:r>
           </a:p>
         </p:txBody>
@@ -11787,7 +10498,7 @@
                 </a:solidFill>
                 <a:latin typeface="Calibri"/>
               </a:rPr>
-              <a:t>Q12  -  Firebase</a:t>
+              <a:t>Q12 — Firebase</a:t>
             </a:r>
           </a:p>
         </p:txBody>
@@ -11829,218 +10540,14 @@
       </p:cxnSp>
       <p:sp>
         <p:nvSpPr>
-          <p:cNvPr id="7" name="Rounded Rectangle 6"/>
-          <p:cNvSpPr/>
-          <p:nvPr/>
-        </p:nvSpPr>
-        <p:spPr>
-          <a:xfrm>
-            <a:off x="502920" y="1691640"/>
-            <a:ext cx="11183112" cy="2204720"/>
-          </a:xfrm>
-          <a:prstGeom prst="roundRect">
-            <a:avLst>
-              <a:gd name="adj" fmla="val 4000"/>
-            </a:avLst>
-          </a:prstGeom>
-          <a:solidFill>
-            <a:srgbClr val="F1F2F6"/>
-          </a:solidFill>
-          <a:ln w="6350">
-            <a:solidFill>
-              <a:srgbClr val="E5E7EB"/>
-            </a:solidFill>
-          </a:ln>
-        </p:spPr>
-        <p:style>
-          <a:lnRef idx="1">
-            <a:schemeClr val="accent1"/>
-          </a:lnRef>
-          <a:fillRef idx="3">
-            <a:schemeClr val="accent1"/>
-          </a:fillRef>
-          <a:effectRef idx="2">
-            <a:schemeClr val="accent1"/>
-          </a:effectRef>
-          <a:fontRef idx="minor">
-            <a:schemeClr val="lt1"/>
-          </a:fontRef>
-        </p:style>
-        <p:txBody>
-          <a:bodyPr rtlCol="0" anchor="ctr" wrap="none" lIns="164592" rIns="164592" tIns="73152" bIns="73152"/>
-          <a:lstStyle/>
-          <a:p>
-            <a:pPr algn="l">
-              <a:spcAft>
-                <a:spcPts val="0"/>
-              </a:spcAft>
-            </a:pPr>
-            <a:r>
-              <a:rPr sz="1300">
-                <a:solidFill>
-                  <a:srgbClr val="1F2129"/>
-                </a:solidFill>
-                <a:latin typeface="Consolas"/>
-              </a:rPr>
-              <a:t>match /users/{uid} {</a:t>
-            </a:r>
-          </a:p>
-          <a:p>
-            <a:pPr algn="l">
-              <a:spcAft>
-                <a:spcPts val="0"/>
-              </a:spcAft>
-            </a:pPr>
-            <a:r>
-              <a:rPr sz="1300">
-                <a:solidFill>
-                  <a:srgbClr val="1F2129"/>
-                </a:solidFill>
-                <a:latin typeface="Consolas"/>
-              </a:rPr>
-              <a:t>  allow read:   if isSelf(uid);</a:t>
-            </a:r>
-          </a:p>
-          <a:p>
-            <a:pPr algn="l">
-              <a:spcAft>
-                <a:spcPts val="0"/>
-              </a:spcAft>
-            </a:pPr>
-            <a:r>
-              <a:rPr sz="1300">
-                <a:solidFill>
-                  <a:srgbClr val="1F2129"/>
-                </a:solidFill>
-                <a:latin typeface="Consolas"/>
-              </a:rPr>
-              <a:t>  allow create: if isSelf(uid);</a:t>
-            </a:r>
-          </a:p>
-          <a:p>
-            <a:pPr algn="l">
-              <a:spcAft>
-                <a:spcPts val="0"/>
-              </a:spcAft>
-            </a:pPr>
-            <a:r>
-              <a:rPr sz="1300">
-                <a:solidFill>
-                  <a:srgbClr val="1F2129"/>
-                </a:solidFill>
-                <a:latin typeface="Consolas"/>
-              </a:rPr>
-              <a:t>  allow update: if isSelf(uid);</a:t>
-            </a:r>
-          </a:p>
-          <a:p>
-            <a:pPr algn="l">
-              <a:spcAft>
-                <a:spcPts val="0"/>
-              </a:spcAft>
-            </a:pPr>
-            <a:r>
-              <a:rPr sz="1300">
-                <a:solidFill>
-                  <a:srgbClr val="1F2129"/>
-                </a:solidFill>
-                <a:latin typeface="Consolas"/>
-              </a:rPr>
-              <a:t>  allow delete: if false;</a:t>
-            </a:r>
-          </a:p>
-          <a:p>
-            <a:pPr algn="l">
-              <a:spcAft>
-                <a:spcPts val="0"/>
-              </a:spcAft>
-            </a:pPr>
-            <a:r>
-              <a:rPr sz="1300">
-                <a:solidFill>
-                  <a:srgbClr val="1F2129"/>
-                </a:solidFill>
-                <a:latin typeface="Consolas"/>
-              </a:rPr>
-              <a:t>}</a:t>
-            </a:r>
-          </a:p>
-          <a:p>
-            <a:pPr algn="l">
-              <a:spcAft>
-                <a:spcPts val="0"/>
-              </a:spcAft>
-            </a:pPr>
-            <a:r>
-              <a:rPr sz="1300">
-                <a:solidFill>
-                  <a:srgbClr val="1F2129"/>
-                </a:solidFill>
-                <a:latin typeface="Consolas"/>
-              </a:rPr>
-              <a:t> </a:t>
-            </a:r>
-          </a:p>
-          <a:p>
-            <a:pPr algn="l">
-              <a:spcAft>
-                <a:spcPts val="0"/>
-              </a:spcAft>
-            </a:pPr>
-            <a:r>
-              <a:rPr sz="1300">
-                <a:solidFill>
-                  <a:srgbClr val="1F2129"/>
-                </a:solidFill>
-                <a:latin typeface="Consolas"/>
-              </a:rPr>
-              <a:t>function isSelf(uid) {</a:t>
-            </a:r>
-          </a:p>
-          <a:p>
-            <a:pPr algn="l">
-              <a:spcAft>
-                <a:spcPts val="0"/>
-              </a:spcAft>
-            </a:pPr>
-            <a:r>
-              <a:rPr sz="1300">
-                <a:solidFill>
-                  <a:srgbClr val="1F2129"/>
-                </a:solidFill>
-                <a:latin typeface="Consolas"/>
-              </a:rPr>
-              <a:t>  return isSignedIn() &amp;&amp; request.auth.uid == uid;</a:t>
-            </a:r>
-          </a:p>
-          <a:p>
-            <a:pPr algn="l">
-              <a:spcAft>
-                <a:spcPts val="0"/>
-              </a:spcAft>
-            </a:pPr>
-            <a:r>
-              <a:rPr sz="1300">
-                <a:solidFill>
-                  <a:srgbClr val="1F2129"/>
-                </a:solidFill>
-                <a:latin typeface="Consolas"/>
-              </a:rPr>
-              <a:t>}</a:t>
-            </a:r>
-          </a:p>
-        </p:txBody>
-      </p:sp>
-      <p:sp>
-        <p:nvSpPr>
-          <p:cNvPr id="8" name="TextBox 7"/>
+          <p:cNvPr id="7" name="TextBox 6"/>
           <p:cNvSpPr txBox="1"/>
           <p:nvPr/>
         </p:nvSpPr>
         <p:spPr>
           <a:xfrm>
-            <a:off x="502920" y="4033520"/>
-            <a:ext cx="11183112" cy="1155700"/>
+            <a:off x="502920" y="1691640"/>
+            <a:ext cx="11183112" cy="1816100"/>
           </a:xfrm>
           <a:prstGeom prst="rect">
             <a:avLst/>
@@ -12065,7 +10572,7 @@
                 </a:solidFill>
                 <a:latin typeface="Calibri"/>
               </a:rPr>
-              <a:t>Unauthenticated:  request.auth == null  -&gt; isSignedIn() false  -&gt; denied</a:t>
+              <a:t>The rule is simple: if the person asking is logged in as you, they can see and change your profile</a:t>
             </a:r>
           </a:p>
           <a:p>
@@ -12081,7 +10588,7 @@
                 </a:solidFill>
                 <a:latin typeface="Calibri"/>
               </a:rPr>
-              <a:t>Wrong UID:  request.auth.uid != uid  -&gt; denied</a:t>
+              <a:t>If they're not logged in, or they're trying to look at someone else's profile, the request is blocked</a:t>
             </a:r>
           </a:p>
           <a:p>
@@ -12097,7 +10604,30 @@
                 </a:solidFill>
                 <a:latin typeface="Calibri"/>
               </a:rPr>
-              <a:t>Hard-off delete:  cleanup goes through a Cloud Function (Admin SDK bypasses rules)</a:t>
+              <a:t>Deleting profiles is turned off completely — that happens through a secure server process instead</a:t>
+            </a:r>
+          </a:p>
+          <a:p>
+            <a:pPr algn="l">
+              <a:spcAft>
+                <a:spcPts val="600"/>
+              </a:spcAft>
+            </a:pPr>
+          </a:p>
+          <a:p>
+            <a:pPr algn="l">
+              <a:spcAft>
+                <a:spcPts val="600"/>
+              </a:spcAft>
+            </a:pPr>
+            <a:r>
+              <a:rPr sz="1800">
+                <a:solidFill>
+                  <a:srgbClr val="1F2129"/>
+                </a:solidFill>
+                <a:latin typeface="Calibri"/>
+              </a:rPr>
+              <a:t>I tested this both in the Firebase console and with automated tests so I know it works.</a:t>
             </a:r>
           </a:p>
         </p:txBody>

</xml_diff>

<commit_message>
docs(presentation): embed 6 real-app screenshots into slides 2, 6, 7, 9, 11, 12, 13, 15 with auto-shrinking body layout
</commit_message>
<xml_diff>
--- a/submission/Vibzcheck_Presentation.pptx
+++ b/submission/Vibzcheck_Presentation.pptx
@@ -5508,16 +5508,40 @@
           </a:fontRef>
         </p:style>
       </p:cxnSp>
-      <p:sp>
-        <p:nvSpPr>
-          <p:cNvPr id="7" name="TextBox 6"/>
+      <p:pic>
+        <p:nvPicPr>
+          <p:cNvPr id="7" name="Picture 6" descr="30_session_with_queue.png"/>
+          <p:cNvPicPr>
+            <a:picLocks noChangeAspect="1"/>
+          </p:cNvPicPr>
+          <p:nvPr/>
+        </p:nvPicPr>
+        <p:blipFill>
+          <a:blip r:embed="rId2"/>
+          <a:stretch>
+            <a:fillRect/>
+          </a:stretch>
+        </p:blipFill>
+        <p:spPr>
+          <a:xfrm>
+            <a:off x="9523600" y="1691640"/>
+            <a:ext cx="2162432" cy="4572000"/>
+          </a:xfrm>
+          <a:prstGeom prst="rect">
+            <a:avLst/>
+          </a:prstGeom>
+        </p:spPr>
+      </p:pic>
+      <p:sp>
+        <p:nvSpPr>
+          <p:cNvPr id="8" name="TextBox 7"/>
           <p:cNvSpPr txBox="1"/>
           <p:nvPr/>
         </p:nvSpPr>
         <p:spPr>
           <a:xfrm>
             <a:off x="502920" y="1691640"/>
-            <a:ext cx="11183112" cy="1155700"/>
+            <a:ext cx="8837800" cy="1155700"/>
           </a:xfrm>
           <a:prstGeom prst="rect">
             <a:avLst/>
@@ -5542,7 +5566,7 @@
                 </a:solidFill>
                 <a:latin typeface="Calibri"/>
               </a:rPr>
-              <a:t>Early bug: tapping the upvote button twice looked correct on screen but the score stayed at 1 in the database</a:t>
+              <a:t>Early bug: tapping upvote twice looked correct but the score stayed at 1 in the database</a:t>
             </a:r>
           </a:p>
           <a:p>
@@ -5558,7 +5582,7 @@
                 </a:solidFill>
                 <a:latin typeface="Calibri"/>
               </a:rPr>
-              <a:t>Root cause: clearing a vote with votes[uid] = null didn't actually remove the key in real Firestore</a:t>
+              <a:t>Cause: clearing a vote with votes[uid] = null didn't remove the key in real Firestore</a:t>
             </a:r>
           </a:p>
           <a:p>
@@ -5574,21 +5598,21 @@
                 </a:solidFill>
                 <a:latin typeface="Calibri"/>
               </a:rPr>
-              <a:t>Fix (shown in code below): use FieldValue.delete() inside a transaction so the vote, score, and counters all update together atomically</a:t>
-            </a:r>
-          </a:p>
-        </p:txBody>
-      </p:sp>
-      <p:sp>
-        <p:nvSpPr>
-          <p:cNvPr id="8" name="Rounded Rectangle 7"/>
+              <a:t>Fix: use FieldValue.delete() inside a transaction — vote, score, and counters update atomically</a:t>
+            </a:r>
+          </a:p>
+        </p:txBody>
+      </p:sp>
+      <p:sp>
+        <p:nvSpPr>
+          <p:cNvPr id="9" name="Rounded Rectangle 8"/>
           <p:cNvSpPr/>
           <p:nvPr/>
         </p:nvSpPr>
         <p:spPr>
           <a:xfrm>
             <a:off x="502920" y="2893060"/>
-            <a:ext cx="11183112" cy="1417320"/>
+            <a:ext cx="8837800" cy="1417320"/>
           </a:xfrm>
           <a:prstGeom prst="roundRect">
             <a:avLst>
@@ -5721,14 +5745,14 @@
       </p:sp>
       <p:sp>
         <p:nvSpPr>
-          <p:cNvPr id="9" name="TextBox 8"/>
+          <p:cNvPr id="10" name="TextBox 9"/>
           <p:cNvSpPr txBox="1"/>
           <p:nvPr/>
         </p:nvSpPr>
         <p:spPr>
           <a:xfrm>
             <a:off x="502920" y="4447540"/>
-            <a:ext cx="11183112" cy="495300"/>
+            <a:ext cx="8837800" cy="495300"/>
           </a:xfrm>
           <a:prstGeom prst="rect">
             <a:avLst/>
@@ -5753,7 +5777,7 @@
                 </a:solidFill>
                 <a:latin typeface="Calibri"/>
               </a:rPr>
-              <a:t>This exact behavior is now locked in by a unit test so it can't regress.</a:t>
+              <a:t>Locked in by a unit test so it can't regress.</a:t>
             </a:r>
           </a:p>
         </p:txBody>
@@ -5965,16 +5989,40 @@
           </a:fontRef>
         </p:style>
       </p:cxnSp>
-      <p:sp>
-        <p:nvSpPr>
-          <p:cNvPr id="7" name="TextBox 6"/>
+      <p:pic>
+        <p:nvPicPr>
+          <p:cNvPr id="7" name="Picture 6" descr="31_add_track_drake.png"/>
+          <p:cNvPicPr>
+            <a:picLocks noChangeAspect="1"/>
+          </p:cNvPicPr>
+          <p:nvPr/>
+        </p:nvPicPr>
+        <p:blipFill>
+          <a:blip r:embed="rId2"/>
+          <a:stretch>
+            <a:fillRect/>
+          </a:stretch>
+        </p:blipFill>
+        <p:spPr>
+          <a:xfrm>
+            <a:off x="9523600" y="1691640"/>
+            <a:ext cx="2162432" cy="4572000"/>
+          </a:xfrm>
+          <a:prstGeom prst="rect">
+            <a:avLst/>
+          </a:prstGeom>
+        </p:spPr>
+      </p:pic>
+      <p:sp>
+        <p:nvSpPr>
+          <p:cNvPr id="8" name="TextBox 7"/>
           <p:cNvSpPr txBox="1"/>
           <p:nvPr/>
         </p:nvSpPr>
         <p:spPr>
           <a:xfrm>
             <a:off x="502920" y="1691640"/>
-            <a:ext cx="11183112" cy="1485900"/>
+            <a:ext cx="8837800" cy="1485900"/>
           </a:xfrm>
           <a:prstGeom prst="rect">
             <a:avLst/>
@@ -5999,7 +6047,7 @@
                 </a:solidFill>
                 <a:latin typeface="Calibri"/>
               </a:rPr>
-              <a:t>The app calls a Cloud Function to search Spotify (so the secret stays safe on the server)</a:t>
+              <a:t>The app calls a Cloud Function to search Spotify (secret stays safe on the server)</a:t>
             </a:r>
           </a:p>
           <a:p>
@@ -6015,7 +6063,7 @@
                 </a:solidFill>
                 <a:latin typeface="Calibri"/>
               </a:rPr>
-              <a:t>If the function is down, rate-limited, or has any other problem, the app falls back to a small built-in list of songs instead of showing nothing</a:t>
+              <a:t>If the function fails, the app falls back to a built-in list instead of showing nothing</a:t>
             </a:r>
           </a:p>
           <a:p>
@@ -6031,7 +6079,7 @@
                 </a:solidFill>
                 <a:latin typeface="Calibri"/>
               </a:rPr>
-              <a:t>I also changed the Add Track screen so it no longer searches automatically when you open it — you have to type something first</a:t>
+              <a:t>Add Track no longer auto-searches when you open it — you type first</a:t>
             </a:r>
           </a:p>
           <a:p>
@@ -6047,7 +6095,7 @@
                 </a:solidFill>
                 <a:latin typeface="Calibri"/>
               </a:rPr>
-              <a:t>This prevents wasting server calls and makes the experience feel faster</a:t>
+              <a:t>Saves server calls and feels faster</a:t>
             </a:r>
           </a:p>
         </p:txBody>
@@ -6259,16 +6307,40 @@
           </a:fontRef>
         </p:style>
       </p:cxnSp>
-      <p:sp>
-        <p:nvSpPr>
-          <p:cNvPr id="7" name="TextBox 6"/>
+      <p:pic>
+        <p:nvPicPr>
+          <p:cNvPr id="7" name="Picture 6" descr="10_signin.png"/>
+          <p:cNvPicPr>
+            <a:picLocks noChangeAspect="1"/>
+          </p:cNvPicPr>
+          <p:nvPr/>
+        </p:nvPicPr>
+        <p:blipFill>
+          <a:blip r:embed="rId2"/>
+          <a:stretch>
+            <a:fillRect/>
+          </a:stretch>
+        </p:blipFill>
+        <p:spPr>
+          <a:xfrm>
+            <a:off x="9523600" y="1691640"/>
+            <a:ext cx="2162432" cy="4572000"/>
+          </a:xfrm>
+          <a:prstGeom prst="rect">
+            <a:avLst/>
+          </a:prstGeom>
+        </p:spPr>
+      </p:pic>
+      <p:sp>
+        <p:nvSpPr>
+          <p:cNvPr id="8" name="TextBox 7"/>
           <p:cNvSpPr txBox="1"/>
           <p:nvPr/>
         </p:nvSpPr>
         <p:spPr>
           <a:xfrm>
             <a:off x="502920" y="1691640"/>
-            <a:ext cx="11183112" cy="1816100"/>
+            <a:ext cx="8837800" cy="1816100"/>
           </a:xfrm>
           <a:prstGeom prst="rect">
             <a:avLst/>
@@ -6293,7 +6365,7 @@
                 </a:solidFill>
                 <a:latin typeface="Calibri"/>
               </a:rPr>
-              <a:t>Instead of showing scary technical messages like 'user-not-found' or 'wrong-password', the app shows one simple message:</a:t>
+              <a:t>Instead of technical messages like 'user-not-found' or 'wrong-password', the app shows one line:</a:t>
             </a:r>
           </a:p>
           <a:p>
@@ -6332,7 +6404,7 @@
                 </a:solidFill>
                 <a:latin typeface="Calibri"/>
               </a:rPr>
-              <a:t>This is deliberate — it stops someone from figuring out which email addresses have accounts in the system (a security best practice).</a:t>
+              <a:t>Deliberate — it stops anyone from figuring out which emails have accounts (security best practice).</a:t>
             </a:r>
           </a:p>
           <a:p>
@@ -6348,7 +6420,7 @@
                 </a:solidFill>
                 <a:latin typeface="Calibri"/>
               </a:rPr>
-              <a:t>Every possible error is covered by 11 automated tests so the friendly message can never accidentally leak technical details.</a:t>
+              <a:t>11 automated tests guarantee the friendly message can never leak technical details.</a:t>
             </a:r>
           </a:p>
         </p:txBody>
@@ -6893,16 +6965,40 @@
           </a:fontRef>
         </p:style>
       </p:cxnSp>
-      <p:sp>
-        <p:nvSpPr>
-          <p:cNvPr id="7" name="TextBox 6"/>
+      <p:pic>
+        <p:nvPicPr>
+          <p:cNvPr id="7" name="Picture 6" descr="50_suggestions_with_why.png"/>
+          <p:cNvPicPr>
+            <a:picLocks noChangeAspect="1"/>
+          </p:cNvPicPr>
+          <p:nvPr/>
+        </p:nvPicPr>
+        <p:blipFill>
+          <a:blip r:embed="rId2"/>
+          <a:stretch>
+            <a:fillRect/>
+          </a:stretch>
+        </p:blipFill>
+        <p:spPr>
+          <a:xfrm>
+            <a:off x="9523600" y="1691640"/>
+            <a:ext cx="2162432" cy="4572000"/>
+          </a:xfrm>
+          <a:prstGeom prst="rect">
+            <a:avLst/>
+          </a:prstGeom>
+        </p:spPr>
+      </p:pic>
+      <p:sp>
+        <p:nvSpPr>
+          <p:cNvPr id="8" name="TextBox 7"/>
           <p:cNvSpPr txBox="1"/>
           <p:nvPr/>
         </p:nvSpPr>
         <p:spPr>
           <a:xfrm>
             <a:off x="502920" y="1691640"/>
-            <a:ext cx="11183112" cy="3136900"/>
+            <a:ext cx="8837800" cy="3136900"/>
           </a:xfrm>
           <a:prstGeom prst="rect">
             <a:avLst/>
@@ -6927,7 +7023,7 @@
                 </a:solidFill>
                 <a:latin typeface="Calibri"/>
               </a:rPr>
-              <a:t>The app suggests the next three songs using simple rules instead of a black-box AI model:</a:t>
+              <a:t>Suggests the next three songs using simple rules — no black-box AI:</a:t>
             </a:r>
           </a:p>
           <a:p>
@@ -6943,7 +7039,7 @@
                 </a:solidFill>
                 <a:latin typeface="Calibri"/>
               </a:rPr>
-              <a:t>   • Does it match the current mood of the room?</a:t>
+              <a:t>   • Does it match the room's current mood?</a:t>
             </a:r>
           </a:p>
           <a:p>
@@ -6959,7 +7055,7 @@
                 </a:solidFill>
                 <a:latin typeface="Calibri"/>
               </a:rPr>
-              <a:t>   • Does it fit with what people usually like?</a:t>
+              <a:t>   • Does it fit what people usually like?</a:t>
             </a:r>
           </a:p>
           <a:p>
@@ -6975,7 +7071,7 @@
                 </a:solidFill>
                 <a:latin typeface="Calibri"/>
               </a:rPr>
-              <a:t>   • Has the same artist played too much already?</a:t>
+              <a:t>   • Has the same artist played too much?</a:t>
             </a:r>
           </a:p>
           <a:p>
@@ -6991,7 +7087,7 @@
                 </a:solidFill>
                 <a:latin typeface="Calibri"/>
               </a:rPr>
-              <a:t>   • Was this song played recently?</a:t>
+              <a:t>   • Was it played recently?</a:t>
             </a:r>
           </a:p>
           <a:p>
@@ -7014,7 +7110,7 @@
                 </a:solidFill>
                 <a:latin typeface="Calibri"/>
               </a:rPr>
-              <a:t>A second 'fairness' step makes sure quieter people still get their songs played — it gives a small boost to tracks from members who haven't had many songs chosen yet.</a:t>
+              <a:t>A 'fairness' step boosts songs from quieter members so they aren't drowned out.</a:t>
             </a:r>
           </a:p>
           <a:p>
@@ -7030,7 +7126,7 @@
                 </a:solidFill>
                 <a:latin typeface="Calibri"/>
               </a:rPr>
-              <a:t>Every suggestion shows a little 'why this one?' explanation so the group can see and trust the reasoning.</a:t>
+              <a:t>Every pick shows its reasoning (see right) so the group can trust it.</a:t>
             </a:r>
           </a:p>
           <a:p>
@@ -7046,7 +7142,7 @@
                 </a:solidFill>
                 <a:latin typeface="Calibri"/>
               </a:rPr>
-              <a:t>Both features are fully tested so they can't break silently.</a:t>
+              <a:t>Both fully tested so they can't break silently.</a:t>
             </a:r>
           </a:p>
         </p:txBody>
@@ -8150,16 +8246,64 @@
           </a:fontRef>
         </p:style>
       </p:cxnSp>
-      <p:sp>
-        <p:nvSpPr>
-          <p:cNvPr id="7" name="TextBox 6"/>
+      <p:pic>
+        <p:nvPicPr>
+          <p:cNvPr id="7" name="Picture 6" descr="30_session_with_queue.png"/>
+          <p:cNvPicPr>
+            <a:picLocks noChangeAspect="1"/>
+          </p:cNvPicPr>
+          <p:nvPr/>
+        </p:nvPicPr>
+        <p:blipFill>
+          <a:blip r:embed="rId2"/>
+          <a:stretch>
+            <a:fillRect/>
+          </a:stretch>
+        </p:blipFill>
+        <p:spPr>
+          <a:xfrm>
+            <a:off x="9696595" y="1691640"/>
+            <a:ext cx="1989437" cy="4206240"/>
+          </a:xfrm>
+          <a:prstGeom prst="rect">
+            <a:avLst/>
+          </a:prstGeom>
+        </p:spPr>
+      </p:pic>
+      <p:pic>
+        <p:nvPicPr>
+          <p:cNvPr id="8" name="Picture 7" descr="20_home_sessions.png"/>
+          <p:cNvPicPr>
+            <a:picLocks noChangeAspect="1"/>
+          </p:cNvPicPr>
+          <p:nvPr/>
+        </p:nvPicPr>
+        <p:blipFill>
+          <a:blip r:embed="rId3"/>
+          <a:stretch>
+            <a:fillRect/>
+          </a:stretch>
+        </p:blipFill>
+        <p:spPr>
+          <a:xfrm>
+            <a:off x="7524278" y="1691640"/>
+            <a:ext cx="1989437" cy="4206240"/>
+          </a:xfrm>
+          <a:prstGeom prst="rect">
+            <a:avLst/>
+          </a:prstGeom>
+        </p:spPr>
+      </p:pic>
+      <p:sp>
+        <p:nvSpPr>
+          <p:cNvPr id="9" name="TextBox 8"/>
           <p:cNvSpPr txBox="1"/>
           <p:nvPr/>
         </p:nvSpPr>
         <p:spPr>
           <a:xfrm>
             <a:off x="502920" y="1691640"/>
-            <a:ext cx="11183112" cy="2146300"/>
+            <a:ext cx="6838478" cy="2146300"/>
           </a:xfrm>
           <a:prstGeom prst="rect">
             <a:avLst/>
@@ -8184,7 +8328,7 @@
                 </a:solidFill>
                 <a:latin typeface="Calibri"/>
               </a:rPr>
-              <a:t>Alice (Device A) creates a session called 'Friday Vibes'</a:t>
+              <a:t>Alice creates a session called 'Friday Vibes'</a:t>
             </a:r>
           </a:p>
           <a:p>
@@ -8200,7 +8344,7 @@
                 </a:solidFill>
                 <a:latin typeface="Calibri"/>
               </a:rPr>
-              <a:t>Bob (Device B) joins using the six-character code Alice reads aloud</a:t>
+              <a:t>Bob joins using the six-character code Alice reads aloud</a:t>
             </a:r>
           </a:p>
           <a:p>
@@ -8216,7 +8360,7 @@
                 </a:solidFill>
                 <a:latin typeface="Calibri"/>
               </a:rPr>
-              <a:t>Both see the same live queue instantly — no refresh button</a:t>
+              <a:t>Both see the same live queue instantly</a:t>
             </a:r>
           </a:p>
           <a:p>
@@ -8232,7 +8376,7 @@
                 </a:solidFill>
                 <a:latin typeface="Calibri"/>
               </a:rPr>
-              <a:t>Alice adds 'Blinding Lights' by The Weeknd from Spotify</a:t>
+              <a:t>Alice adds 'Blinding Lights' from Spotify</a:t>
             </a:r>
           </a:p>
           <a:p>
@@ -8248,7 +8392,7 @@
                 </a:solidFill>
                 <a:latin typeface="Calibri"/>
               </a:rPr>
-              <a:t>Bob upvotes it — the vote count updates on both screens in real time</a:t>
+              <a:t>Bob upvotes — the count updates on both screens in real time</a:t>
             </a:r>
           </a:p>
           <a:p>
@@ -8264,7 +8408,7 @@
                 </a:solidFill>
                 <a:latin typeface="Calibri"/>
               </a:rPr>
-              <a:t>Open the Suggestions tab to see the AI helper explain why it picked the next song</a:t>
+              <a:t>The AI suggests the next song and explains why</a:t>
             </a:r>
           </a:p>
         </p:txBody>
@@ -9532,16 +9676,40 @@
           </a:fontRef>
         </p:style>
       </p:cxnSp>
-      <p:sp>
-        <p:nvSpPr>
-          <p:cNvPr id="7" name="TextBox 6"/>
+      <p:pic>
+        <p:nvPicPr>
+          <p:cNvPr id="7" name="Picture 6" descr="20_home_sessions.png"/>
+          <p:cNvPicPr>
+            <a:picLocks noChangeAspect="1"/>
+          </p:cNvPicPr>
+          <p:nvPr/>
+        </p:nvPicPr>
+        <p:blipFill>
+          <a:blip r:embed="rId2"/>
+          <a:stretch>
+            <a:fillRect/>
+          </a:stretch>
+        </p:blipFill>
+        <p:spPr>
+          <a:xfrm>
+            <a:off x="9523600" y="1691640"/>
+            <a:ext cx="2162432" cy="4572000"/>
+          </a:xfrm>
+          <a:prstGeom prst="rect">
+            <a:avLst/>
+          </a:prstGeom>
+        </p:spPr>
+      </p:pic>
+      <p:sp>
+        <p:nvSpPr>
+          <p:cNvPr id="8" name="TextBox 7"/>
           <p:cNvSpPr txBox="1"/>
           <p:nvPr/>
         </p:nvSpPr>
         <p:spPr>
           <a:xfrm>
             <a:off x="502920" y="1691640"/>
-            <a:ext cx="11183112" cy="3136900"/>
+            <a:ext cx="8837800" cy="2806700"/>
           </a:xfrm>
           <a:prstGeom prst="rect">
             <a:avLst/>
@@ -9582,7 +9750,7 @@
                 </a:solidFill>
                 <a:latin typeface="Calibri"/>
               </a:rPr>
-              <a:t>   • users — profile pictures and preferences</a:t>
+              <a:t>   • users — profile and preferences</a:t>
             </a:r>
           </a:p>
           <a:p>
@@ -9598,7 +9766,7 @@
                 </a:solidFill>
                 <a:latin typeface="Calibri"/>
               </a:rPr>
-              <a:t>   • sessions — the playlist room itself (title, owner, who is in it)</a:t>
+              <a:t>   • sessions — the playlist room itself</a:t>
             </a:r>
           </a:p>
           <a:p>
@@ -9614,7 +9782,7 @@
                 </a:solidFill>
                 <a:latin typeface="Calibri"/>
               </a:rPr>
-              <a:t>   • joinCodes — a simple lookup so friends can join with a 6-letter code</a:t>
+              <a:t>   • joinCodes — lookup so friends can join with a 6-letter code</a:t>
             </a:r>
           </a:p>
           <a:p>
@@ -9637,7 +9805,7 @@
                 </a:solidFill>
                 <a:latin typeface="Calibri"/>
               </a:rPr>
-              <a:t>Inside each session there are smaller lists:</a:t>
+              <a:t>Inside each session: members, queue (songs), messages (chat), suggestions (AI)</a:t>
             </a:r>
           </a:p>
           <a:p>
@@ -9646,6 +9814,13 @@
                 <a:spcPts val="600"/>
               </a:spcAft>
             </a:pPr>
+          </a:p>
+          <a:p>
+            <a:pPr algn="l">
+              <a:spcAft>
+                <a:spcPts val="600"/>
+              </a:spcAft>
+            </a:pPr>
             <a:r>
               <a:rPr sz="1800">
                 <a:solidFill>
@@ -9653,30 +9828,7 @@
                 </a:solidFill>
                 <a:latin typeface="Calibri"/>
               </a:rPr>
-              <a:t>   • members, queue (the songs), messages (chat), and suggestions (AI ideas)</a:t>
-            </a:r>
-          </a:p>
-          <a:p>
-            <a:pPr algn="l">
-              <a:spcAft>
-                <a:spcPts val="600"/>
-              </a:spcAft>
-            </a:pPr>
-          </a:p>
-          <a:p>
-            <a:pPr algn="l">
-              <a:spcAft>
-                <a:spcPts val="600"/>
-              </a:spcAft>
-            </a:pPr>
-            <a:r>
-              <a:rPr sz="1800">
-                <a:solidFill>
-                  <a:srgbClr val="1F2129"/>
-                </a:solidFill>
-                <a:latin typeface="Calibri"/>
-              </a:rPr>
-              <a:t>This structure makes the security rules simple and the screens fast — when you leave a session, everything cleans up automatically.</a:t>
+              <a:t>This makes security rules simple and screens fast — leaving cleans up automatically.</a:t>
             </a:r>
           </a:p>
         </p:txBody>
@@ -9888,16 +10040,40 @@
           </a:fontRef>
         </p:style>
       </p:cxnSp>
-      <p:sp>
-        <p:nvSpPr>
-          <p:cNvPr id="7" name="TextBox 6"/>
+      <p:pic>
+        <p:nvPicPr>
+          <p:cNvPr id="7" name="Picture 6" descr="30_session_with_queue.png"/>
+          <p:cNvPicPr>
+            <a:picLocks noChangeAspect="1"/>
+          </p:cNvPicPr>
+          <p:nvPr/>
+        </p:nvPicPr>
+        <p:blipFill>
+          <a:blip r:embed="rId2"/>
+          <a:stretch>
+            <a:fillRect/>
+          </a:stretch>
+        </p:blipFill>
+        <p:spPr>
+          <a:xfrm>
+            <a:off x="9523600" y="1691640"/>
+            <a:ext cx="2162432" cy="4572000"/>
+          </a:xfrm>
+          <a:prstGeom prst="rect">
+            <a:avLst/>
+          </a:prstGeom>
+        </p:spPr>
+      </p:pic>
+      <p:sp>
+        <p:nvSpPr>
+          <p:cNvPr id="8" name="TextBox 7"/>
           <p:cNvSpPr txBox="1"/>
           <p:nvPr/>
         </p:nvSpPr>
         <p:spPr>
           <a:xfrm>
             <a:off x="502920" y="1691640"/>
-            <a:ext cx="11183112" cy="2476500"/>
+            <a:ext cx="8837800" cy="2476500"/>
           </a:xfrm>
           <a:prstGeom prst="rect">
             <a:avLst/>
@@ -9922,7 +10098,7 @@
                 </a:solidFill>
                 <a:latin typeface="Calibri"/>
               </a:rPr>
-              <a:t>Early version: to join you had to be able to see every session — that broke the privacy rules</a:t>
+              <a:t>Early version: to join you had to see every session — that broke privacy rules</a:t>
             </a:r>
           </a:p>
           <a:p>
@@ -9954,7 +10130,7 @@
                 </a:solidFill>
                 <a:latin typeface="Calibri"/>
               </a:rPr>
-              <a:t>   1. A small public lookup table (joinCodes) that anyone logged in can read</a:t>
+              <a:t>   1. A small public lookup table (joinCodes) anyone logged in can read</a:t>
             </a:r>
           </a:p>
           <a:p>
@@ -9970,7 +10146,7 @@
                 </a:solidFill>
                 <a:latin typeface="Calibri"/>
               </a:rPr>
-              <a:t>   2. A special rule that lets a new person add ONLY themselves to the member list</a:t>
+              <a:t>   2. A rule that lets a new person add ONLY themselves to the member list</a:t>
             </a:r>
           </a:p>
           <a:p>
@@ -9993,7 +10169,7 @@
                 </a:solidFill>
                 <a:latin typeface="Calibri"/>
               </a:rPr>
-              <a:t>This pattern is now my go-to whenever I need a 'share this link' feature.</a:t>
+              <a:t>This pattern is now my go-to for any 'share this link' feature.</a:t>
             </a:r>
           </a:p>
           <a:p>
@@ -10009,7 +10185,7 @@
                 </a:solidFill>
                 <a:latin typeface="Calibri"/>
               </a:rPr>
-              <a:t>It was the hardest bug I fixed — see Bug 2 in the bug log.</a:t>
+              <a:t>Hardest bug I fixed — see Bug 2 in the bug log.</a:t>
             </a:r>
           </a:p>
         </p:txBody>
@@ -10538,16 +10714,40 @@
           </a:fontRef>
         </p:style>
       </p:cxnSp>
-      <p:sp>
-        <p:nvSpPr>
-          <p:cNvPr id="7" name="TextBox 6"/>
+      <p:pic>
+        <p:nvPicPr>
+          <p:cNvPr id="7" name="Picture 6" descr="11_signup.png"/>
+          <p:cNvPicPr>
+            <a:picLocks noChangeAspect="1"/>
+          </p:cNvPicPr>
+          <p:nvPr/>
+        </p:nvPicPr>
+        <p:blipFill>
+          <a:blip r:embed="rId2"/>
+          <a:stretch>
+            <a:fillRect/>
+          </a:stretch>
+        </p:blipFill>
+        <p:spPr>
+          <a:xfrm>
+            <a:off x="9523600" y="1691640"/>
+            <a:ext cx="2162432" cy="4572000"/>
+          </a:xfrm>
+          <a:prstGeom prst="rect">
+            <a:avLst/>
+          </a:prstGeom>
+        </p:spPr>
+      </p:pic>
+      <p:sp>
+        <p:nvSpPr>
+          <p:cNvPr id="8" name="TextBox 7"/>
           <p:cNvSpPr txBox="1"/>
           <p:nvPr/>
         </p:nvSpPr>
         <p:spPr>
           <a:xfrm>
             <a:off x="502920" y="1691640"/>
-            <a:ext cx="11183112" cy="1816100"/>
+            <a:ext cx="8837800" cy="1816100"/>
           </a:xfrm>
           <a:prstGeom prst="rect">
             <a:avLst/>
@@ -10572,7 +10772,7 @@
                 </a:solidFill>
                 <a:latin typeface="Calibri"/>
               </a:rPr>
-              <a:t>The rule is simple: if the person asking is logged in as you, they can see and change your profile</a:t>
+              <a:t>Rule: if the person asking is logged in as you, they can read and change your profile</a:t>
             </a:r>
           </a:p>
           <a:p>
@@ -10588,7 +10788,7 @@
                 </a:solidFill>
                 <a:latin typeface="Calibri"/>
               </a:rPr>
-              <a:t>If they're not logged in, or they're trying to look at someone else's profile, the request is blocked</a:t>
+              <a:t>If they're not logged in, or they're looking at someone else's profile, the request is blocked</a:t>
             </a:r>
           </a:p>
           <a:p>
@@ -10604,7 +10804,7 @@
                 </a:solidFill>
                 <a:latin typeface="Calibri"/>
               </a:rPr>
-              <a:t>Deleting profiles is turned off completely — that happens through a secure server process instead</a:t>
+              <a:t>Deleting profiles is turned off completely — handled through a secure server process</a:t>
             </a:r>
           </a:p>
           <a:p>
@@ -10627,7 +10827,7 @@
                 </a:solidFill>
                 <a:latin typeface="Calibri"/>
               </a:rPr>
-              <a:t>I tested this both in the Firebase console and with automated tests so I know it works.</a:t>
+              <a:t>I tested this in the Firebase console and with automated tests so I know it works.</a:t>
             </a:r>
           </a:p>
         </p:txBody>

</xml_diff>

<commit_message>
slides: embed 4 new screenshots (chat, create+join, device B sync proof)
Slide 2 now shows the live demo as Device A (E85 has 1 upvote) next to
Device B (E85 has 2 after the joiner upvotes) -- proves the realtime
sync visually instead of describing it. Slide 5 gets the chat screen,
slide 7 gets the literal create + join screens, slide 8 gets the home
session list image to anchor the 'under 200 ms' claim.

Renderer now reads each PNG's true aspect (so the wider Device B
capture, which includes the emulator window chrome, no longer
distorts).
</commit_message>
<xml_diff>
--- a/submission/Vibzcheck_Presentation.pptx
+++ b/submission/Vibzcheck_Presentation.pptx
@@ -8248,7 +8248,7 @@
       </p:cxnSp>
       <p:pic>
         <p:nvPicPr>
-          <p:cNvPr id="7" name="Picture 6" descr="30_session_with_queue.png"/>
+          <p:cNvPr id="7" name="Picture 6" descr="40_session_device_b.png"/>
           <p:cNvPicPr>
             <a:picLocks noChangeAspect="1"/>
           </p:cNvPicPr>
@@ -8262,8 +8262,8 @@
         </p:blipFill>
         <p:spPr>
           <a:xfrm>
-            <a:off x="9696595" y="1691640"/>
-            <a:ext cx="1989437" cy="4206240"/>
+            <a:off x="9867245" y="1691640"/>
+            <a:ext cx="1818787" cy="4206240"/>
           </a:xfrm>
           <a:prstGeom prst="rect">
             <a:avLst/>
@@ -8272,7 +8272,7 @@
       </p:pic>
       <p:pic>
         <p:nvPicPr>
-          <p:cNvPr id="8" name="Picture 7" descr="20_home_sessions.png"/>
+          <p:cNvPr id="8" name="Picture 7" descr="30_session_with_queue.png"/>
           <p:cNvPicPr>
             <a:picLocks noChangeAspect="1"/>
           </p:cNvPicPr>
@@ -8286,7 +8286,7 @@
         </p:blipFill>
         <p:spPr>
           <a:xfrm>
-            <a:off x="7524278" y="1691640"/>
+            <a:off x="7694928" y="1691640"/>
             <a:ext cx="1989437" cy="4206240"/>
           </a:xfrm>
           <a:prstGeom prst="rect">
@@ -8303,7 +8303,7 @@
         <p:spPr>
           <a:xfrm>
             <a:off x="502920" y="1691640"/>
-            <a:ext cx="6838478" cy="2146300"/>
+            <a:ext cx="7009128" cy="2146300"/>
           </a:xfrm>
           <a:prstGeom prst="rect">
             <a:avLst/>
@@ -9327,16 +9327,40 @@
           </a:fontRef>
         </p:style>
       </p:cxnSp>
-      <p:sp>
-        <p:nvSpPr>
-          <p:cNvPr id="7" name="TextBox 6"/>
+      <p:pic>
+        <p:nvPicPr>
+          <p:cNvPr id="7" name="Picture 6" descr="60_chat.png"/>
+          <p:cNvPicPr>
+            <a:picLocks noChangeAspect="1"/>
+          </p:cNvPicPr>
+          <p:nvPr/>
+        </p:nvPicPr>
+        <p:blipFill>
+          <a:blip r:embed="rId2"/>
+          <a:stretch>
+            <a:fillRect/>
+          </a:stretch>
+        </p:blipFill>
+        <p:spPr>
+          <a:xfrm>
+            <a:off x="9523600" y="1691640"/>
+            <a:ext cx="2162432" cy="4572000"/>
+          </a:xfrm>
+          <a:prstGeom prst="rect">
+            <a:avLst/>
+          </a:prstGeom>
+        </p:spPr>
+      </p:pic>
+      <p:sp>
+        <p:nvSpPr>
+          <p:cNvPr id="8" name="TextBox 7"/>
           <p:cNvSpPr txBox="1"/>
           <p:nvPr/>
         </p:nvSpPr>
         <p:spPr>
           <a:xfrm>
             <a:off x="502920" y="1691640"/>
-            <a:ext cx="11183112" cy="2806700"/>
+            <a:ext cx="8837800" cy="2476500"/>
           </a:xfrm>
           <a:prstGeom prst="rect">
             <a:avLst/>
@@ -9361,7 +9385,7 @@
                 </a:solidFill>
                 <a:latin typeface="Calibri"/>
               </a:rPr>
-              <a:t>The main session screen used to try to do everything at once (playlist, chat, suggestions)</a:t>
+              <a:t>The main session screen used to try to do everything at once</a:t>
             </a:r>
           </a:p>
           <a:p>
@@ -9409,7 +9433,7 @@
                 </a:solidFill>
                 <a:latin typeface="Calibri"/>
               </a:rPr>
-              <a:t>   • SuggestionsCard — shows the AI's next-song ideas with explanations</a:t>
+              <a:t>   • SuggestionsCard — shows the AI's next-song ideas</a:t>
             </a:r>
           </a:p>
           <a:p>
@@ -9425,7 +9449,7 @@
                 </a:solidFill>
                 <a:latin typeface="Calibri"/>
               </a:rPr>
-              <a:t>   • ChatScreen — its own page so you can switch away and come back</a:t>
+              <a:t>   • ChatScreen — its own page (right) so you can switch away and come back</a:t>
             </a:r>
           </a:p>
           <a:p>
@@ -9449,22 +9473,6 @@
                 <a:latin typeface="Calibri"/>
               </a:rPr>
               <a:t>Navigation remembers whether you're logged in and sends you to the right place automatically.</a:t>
-            </a:r>
-          </a:p>
-          <a:p>
-            <a:pPr algn="l">
-              <a:spcAft>
-                <a:spcPts val="600"/>
-              </a:spcAft>
-            </a:pPr>
-            <a:r>
-              <a:rPr sz="1800">
-                <a:solidFill>
-                  <a:srgbClr val="1F2129"/>
-                </a:solidFill>
-                <a:latin typeface="Calibri"/>
-              </a:rPr>
-              <a:t>Adding a new screen later is just one line of code.</a:t>
             </a:r>
           </a:p>
         </p:txBody>
@@ -10042,7 +10050,7 @@
       </p:cxnSp>
       <p:pic>
         <p:nvPicPr>
-          <p:cNvPr id="7" name="Picture 6" descr="30_session_with_queue.png"/>
+          <p:cNvPr id="7" name="Picture 6" descr="22_join_by_code.png"/>
           <p:cNvPicPr>
             <a:picLocks noChangeAspect="1"/>
           </p:cNvPicPr>
@@ -10056,24 +10064,48 @@
         </p:blipFill>
         <p:spPr>
           <a:xfrm>
-            <a:off x="9523600" y="1691640"/>
-            <a:ext cx="2162432" cy="4572000"/>
+            <a:off x="9696595" y="1691640"/>
+            <a:ext cx="1989437" cy="4206240"/>
           </a:xfrm>
           <a:prstGeom prst="rect">
             <a:avLst/>
           </a:prstGeom>
         </p:spPr>
       </p:pic>
-      <p:sp>
-        <p:nvSpPr>
-          <p:cNvPr id="8" name="TextBox 7"/>
+      <p:pic>
+        <p:nvPicPr>
+          <p:cNvPr id="8" name="Picture 7" descr="21_create_session.png"/>
+          <p:cNvPicPr>
+            <a:picLocks noChangeAspect="1"/>
+          </p:cNvPicPr>
+          <p:nvPr/>
+        </p:nvPicPr>
+        <p:blipFill>
+          <a:blip r:embed="rId3"/>
+          <a:stretch>
+            <a:fillRect/>
+          </a:stretch>
+        </p:blipFill>
+        <p:spPr>
+          <a:xfrm>
+            <a:off x="7524278" y="1691640"/>
+            <a:ext cx="1989437" cy="4206240"/>
+          </a:xfrm>
+          <a:prstGeom prst="rect">
+            <a:avLst/>
+          </a:prstGeom>
+        </p:spPr>
+      </p:pic>
+      <p:sp>
+        <p:nvSpPr>
+          <p:cNvPr id="9" name="TextBox 8"/>
           <p:cNvSpPr txBox="1"/>
           <p:nvPr/>
         </p:nvSpPr>
         <p:spPr>
           <a:xfrm>
             <a:off x="502920" y="1691640"/>
-            <a:ext cx="8837800" cy="2476500"/>
+            <a:ext cx="6838478" cy="2476500"/>
           </a:xfrm>
           <a:prstGeom prst="rect">
             <a:avLst/>
@@ -10098,7 +10130,7 @@
                 </a:solidFill>
                 <a:latin typeface="Calibri"/>
               </a:rPr>
-              <a:t>Early version: to join you had to see every session — that broke privacy rules</a:t>
+              <a:t>Host creates the room (left), shares a 6-character code; joiner types it (right)</a:t>
             </a:r>
           </a:p>
           <a:p>
@@ -10114,7 +10146,7 @@
                 </a:solidFill>
                 <a:latin typeface="Calibri"/>
               </a:rPr>
-              <a:t>Solution:</a:t>
+              <a:t>Early version: to join you had to see every session — that broke privacy rules</a:t>
             </a:r>
           </a:p>
           <a:p>
@@ -10130,7 +10162,7 @@
                 </a:solidFill>
                 <a:latin typeface="Calibri"/>
               </a:rPr>
-              <a:t>   1. A small public lookup table (joinCodes) anyone logged in can read</a:t>
+              <a:t>Solution:</a:t>
             </a:r>
           </a:p>
           <a:p>
@@ -10146,7 +10178,7 @@
                 </a:solidFill>
                 <a:latin typeface="Calibri"/>
               </a:rPr>
-              <a:t>   2. A rule that lets a new person add ONLY themselves to the member list</a:t>
+              <a:t>   1. A small public lookup table (joinCodes) anyone logged in can read</a:t>
             </a:r>
           </a:p>
           <a:p>
@@ -10155,6 +10187,15 @@
                 <a:spcPts val="600"/>
               </a:spcAft>
             </a:pPr>
+            <a:r>
+              <a:rPr sz="1800">
+                <a:solidFill>
+                  <a:srgbClr val="1F2129"/>
+                </a:solidFill>
+                <a:latin typeface="Calibri"/>
+              </a:rPr>
+              <a:t>   2. A rule that lets a new person add ONLY themselves to the member list</a:t>
+            </a:r>
           </a:p>
           <a:p>
             <a:pPr algn="l">
@@ -10162,15 +10203,6 @@
                 <a:spcPts val="600"/>
               </a:spcAft>
             </a:pPr>
-            <a:r>
-              <a:rPr sz="1800">
-                <a:solidFill>
-                  <a:srgbClr val="1F2129"/>
-                </a:solidFill>
-                <a:latin typeface="Calibri"/>
-              </a:rPr>
-              <a:t>This pattern is now my go-to for any 'share this link' feature.</a:t>
-            </a:r>
           </a:p>
           <a:p>
             <a:pPr algn="l">
@@ -10397,16 +10429,40 @@
           </a:fontRef>
         </p:style>
       </p:cxnSp>
-      <p:sp>
-        <p:nvSpPr>
-          <p:cNvPr id="7" name="TextBox 6"/>
+      <p:pic>
+        <p:nvPicPr>
+          <p:cNvPr id="7" name="Picture 6" descr="20_home_sessions.png"/>
+          <p:cNvPicPr>
+            <a:picLocks noChangeAspect="1"/>
+          </p:cNvPicPr>
+          <p:nvPr/>
+        </p:nvPicPr>
+        <p:blipFill>
+          <a:blip r:embed="rId2"/>
+          <a:stretch>
+            <a:fillRect/>
+          </a:stretch>
+        </p:blipFill>
+        <p:spPr>
+          <a:xfrm>
+            <a:off x="9523600" y="1691640"/>
+            <a:ext cx="2162432" cy="4572000"/>
+          </a:xfrm>
+          <a:prstGeom prst="rect">
+            <a:avLst/>
+          </a:prstGeom>
+        </p:spPr>
+      </p:pic>
+      <p:sp>
+        <p:nvSpPr>
+          <p:cNvPr id="8" name="TextBox 7"/>
           <p:cNvSpPr txBox="1"/>
           <p:nvPr/>
         </p:nvSpPr>
         <p:spPr>
           <a:xfrm>
             <a:off x="502920" y="1691640"/>
-            <a:ext cx="11183112" cy="2146300"/>
+            <a:ext cx="8837800" cy="2146300"/>
           </a:xfrm>
           <a:prstGeom prst="rect">
             <a:avLst/>
@@ -10463,7 +10519,7 @@
                 </a:solidFill>
                 <a:latin typeface="Calibri"/>
               </a:rPr>
-              <a:t>I added it to a file called firestore.indexes.json so it gets deployed automatically</a:t>
+              <a:t>I added it to firestore.indexes.json so it deploys automatically</a:t>
             </a:r>
           </a:p>
           <a:p>
@@ -10486,7 +10542,7 @@
                 </a:solidFill>
                 <a:latin typeface="Calibri"/>
               </a:rPr>
-              <a:t>Without it the screen would spin forever. With it the list appears in under 200 milliseconds.</a:t>
+              <a:t>Without it the screen spun forever. With it the list (right) appears in under 200 ms.</a:t>
             </a:r>
           </a:p>
           <a:p>

</xml_diff>